<commit_message>
Fondos de empleados: convenio en variante ENTIDAD (afiliados), carta de postulacion con calidad del postulado (colaborador, conyuge, hijo desde 12) y colaborador que respalda; presentacion con inicio 3 de noviembre sin pausa en diciembre y beca para conyuge e hijos
Co-Authored-By: Claude Fable 5.1 <noreply@anthropic.com>
</commit_message>
<xml_diff>
--- a/recursos/comercial/B2B/PRESENTACION_FONDOS_EMPLEADOS_HEIIU.pptx
+++ b/recursos/comercial/B2B/PRESENTACION_FONDOS_EMPLEADOS_HEIIU.pptx
@@ -8187,7 +8187,7 @@
                 </a:solidFill>
                 <a:latin typeface="Segoe UI"/>
               </a:rPr>
-              <a:t>beca del 45% sobre el programa completo, para él y para sus hijos.</a:t>
+              <a:t>beca del 45% sobre el programa completo, para él, su cónyuge y sus hijos desde los 12 años.</a:t>
             </a:r>
           </a:p>
           <a:p>
@@ -8946,7 +8946,7 @@
                 </a:solidFill>
                 <a:latin typeface="Constantia"/>
               </a:rPr>
-              <a:t>GRUPOS DE MÁXIMO 16</a:t>
+              <a:t>INICIO 3 DE NOVIEMBRE</a:t>
             </a:r>
           </a:p>
         </p:txBody>
@@ -8988,7 +8988,7 @@
                 </a:solidFill>
                 <a:latin typeface="Segoe UI"/>
               </a:rPr>
-              <a:t>El cupo se asigna por orden de matrícula con la inicial pagada. Próximo inicio: martes 3 de noviembre de 2026.</a:t>
+              <a:t>Grupos de máximo 16; el cupo se asigna por orden de matrícula con la inicial pagada. El grupo no para en diciembre: sigue hasta terminar el nivel, solo descansa los festivos.</a:t>
             </a:r>
           </a:p>
         </p:txBody>

</xml_diff>

<commit_message>
Presentacion fondos de empleados v4: maximo tres lineas cortas por diapositiva (el detalle queda en la hoja y en las notas) y paleta mas clara (azul medio en vez de tinta)
Co-Authored-By: Claude Fable 5.1 <noreply@anthropic.com>
</commit_message>
<xml_diff>
--- a/recursos/comercial/B2B/PRESENTACION_FONDOS_EMPLEADOS_HEIIU.pptx
+++ b/recursos/comercial/B2B/PRESENTACION_FONDOS_EMPLEADOS_HEIIU.pptx
@@ -588,7 +588,7 @@
           <a:lstStyle/>
           <a:p>
             <a:r>
-              <a:t>QUÉ DECIR (máximo 20 segundos, no más): "Somos una academia de Bucaramanga con licencia de la Secretaría de Educación desde 2012 y certificación ISO 9001 e ICONTEC. Un solo programa, de A1 a B2, presencial. Y lo que ninguna otra firma: la garantía por escrito." El detalle está en la hoja que se deja al final. Hablar de la academia más de 2 minutos baja el cierre.</a:t>
+              <a:t>QUÉ DECIR (máximo 20 segundos): "Somos una academia de Bucaramanga con licencia de la Secretaría de Educación desde 2012 y certificación ISO 9001 e ICONTEC. Un solo programa, de A1 a B2, presencial. Y lo que ninguna otra firma: la garantía por escrito." El detalle está en la hoja que se deja al final. Hablar de la academia más de 2 minutos baja el cierre.</a:t>
             </a:r>
           </a:p>
         </p:txBody>
@@ -658,12 +658,12 @@
           <a:lstStyle/>
           <a:p>
             <a:r>
-              <a:t>QUÉ DECIR: "Es un programa completo, presencial, en nuestra sede, en la mañana o en la noche; con 8 afiliados o más, el horario lo pone el fondo. Un profesor por grupo de máximo 16, y evaluador externo al cierre de cada nivel. Y lo firmamos: si cumple y no avanza, devolvemos el nivel."</a:t>
-            </a:r>
-          </a:p>
-          <a:p>
-            <a:r>
-              <a:t>NO leer las seis casillas. Si pregunta por una, responde en una frase: el detalle está en la hoja.</a:t>
+              <a:t>QUÉ DECIR: "Programa completo, presencial, en la mañana o en la noche; con 8 afiliados o más, el horario lo pone el fondo. Un profesor por grupo de máximo 16 y evaluador externo al cierre de cada nivel. Y lo firmamos: si cumple y no avanza, devolvemos el nivel."</a:t>
+            </a:r>
+          </a:p>
+          <a:p>
+            <a:r>
+              <a:t>Horarios exactos: mañana 8:00 a 12:00, noche 6:30 a 8:30 p. m., sábados 8:00 a 12:00. Todo está en la hoja; no leer las seis casillas.</a:t>
             </a:r>
           </a:p>
         </p:txBody>
@@ -738,7 +738,7 @@
           </a:p>
           <a:p>
             <a:r>
-              <a:t>Si el fondo quiere pagar los cupos: Plan Empresa, $4.782.800 por cupo de 3 a 7, $4.350.000 de 8 a 15, $3.950.000 de 16 a 30 (está en la hoja). NO recitar la tabla. "Beca", nunca "descuento".</a:t>
+              <a:t>A cuotas con la academia: $5.565.440 (36%); ejemplo $1.113.088 hoy y 11 cuotas de $452.348. Plan Empresa si el fondo paga los cupos: $4.782.800 por cupo de 3 a 7, $4.350.000 de 8 a 15, $3.950.000 de 16 a 30. Todo en la hoja. "Beca", nunca "descuento".</a:t>
             </a:r>
           </a:p>
         </p:txBody>
@@ -808,7 +808,7 @@
           <a:lstStyle/>
           <a:p>
             <a:r>
-              <a:t>QUÉ DECIR: "Para el fondo es un beneficio más en su portafolio, con su nombre y sin tocar presupuesto: usted postula con una carta y nosotros hacemos el resto. Para el afiliado es pagar la mitad, con garantía, y que lo acompañen hasta que hable." Decir UN dato, no todos.</a:t>
+              <a:t>QUÉ DECIR: "Para el fondo es un beneficio más en su portafolio, con su nombre y sin tocar presupuesto: usted postula con una carta y nosotros hacemos el resto. Para el afiliado es pagar la mitad, con garantía, y que lo acompañen hasta que hable." UN dato si hace falta: quien certifica su inglés gana cerca de un 26% más (DNP). Diagnóstico de nivel para 10 afiliados sin costo la semana siguiente a la firma.</a:t>
             </a:r>
           </a:p>
           <a:p>
@@ -883,7 +883,7 @@
           <a:lstStyle/>
           <a:p>
             <a:r>
-              <a:t>QUÉ DECIR: "Le hablo hoy y no el mes entrante por una razón: el grupo arranca el martes 3 de noviembre y no para en diciembre. Si firmamos esta semana, sus afiliados alcanzan a entrar. El convenio no tiene costo ni obligaciones, se firma en una hoja, dura 12 meses y se termina con aviso de 30 días. Lo único que le pido es 20 minutos con sus afiliados."</a:t>
+              <a:t>QUÉ DECIR: "Le hablo hoy y no el mes entrante por una razón: el grupo arranca el martes 3 de noviembre y no para en diciembre; solo descansa los festivos. Si firmamos esta semana, sus afiliados alcanzan a entrar. El convenio no tiene costo ni obligaciones, se firma en una hoja, dura 12 meses y se termina con aviso de 30 días. Lo único que le pido es 20 minutos con sus afiliados."</a:t>
             </a:r>
           </a:p>
           <a:p>
@@ -3989,7 +3989,7 @@
             <a:avLst/>
           </a:prstGeom>
           <a:solidFill>
-            <a:srgbClr val="0F1B2D"/>
+            <a:srgbClr val="2B5A8C"/>
           </a:solidFill>
           <a:ln>
             <a:noFill/>
@@ -4033,7 +4033,7 @@
             <a:avLst/>
           </a:prstGeom>
           <a:solidFill>
-            <a:srgbClr val="1B2A41"/>
+            <a:srgbClr val="3D6FA6"/>
           </a:solidFill>
           <a:ln>
             <a:noFill/>
@@ -4163,7 +4163,7 @@
             <a:r>
               <a:rPr sz="1100" b="1" i="0" spc="250">
                 <a:solidFill>
-                  <a:srgbClr val="E54C09"/>
+                  <a:srgbClr val="FBC900"/>
                 </a:solidFill>
                 <a:latin typeface="Lato"/>
               </a:rPr>
@@ -4205,7 +4205,7 @@
             <a:r>
               <a:rPr sz="4200" b="1" i="0">
                 <a:solidFill>
-                  <a:srgbClr val="F6F1E9"/>
+                  <a:srgbClr val="FFFFFF"/>
                 </a:solidFill>
                 <a:latin typeface="Lato Black"/>
               </a:rPr>
@@ -4256,11 +4256,11 @@
             <a:r>
               <a:rPr sz="1800" b="0" i="0">
                 <a:solidFill>
-                  <a:srgbClr val="C9D0DB"/>
+                  <a:srgbClr val="D6E2F0"/>
                 </a:solidFill>
                 <a:latin typeface="Lato"/>
               </a:rPr>
-              <a:t>Programa presencial de A1 a B2 en Bucaramanga, con garantía de aprendizaje por escrito.</a:t>
+              <a:t>Presencial, en Bucaramanga. Con garantía de aprendizaje por escrito.</a:t>
             </a:r>
           </a:p>
         </p:txBody>
@@ -4298,7 +4298,7 @@
             <a:r>
               <a:rPr sz="1300" b="0" i="0">
                 <a:solidFill>
-                  <a:srgbClr val="7A828F"/>
+                  <a:srgbClr val="D6E2F0"/>
                 </a:solidFill>
                 <a:latin typeface="Lato"/>
               </a:rPr>
@@ -4307,7 +4307,7 @@
             <a:r>
               <a:rPr sz="1300" b="0" i="0">
                 <a:solidFill>
-                  <a:srgbClr val="9AA4B5"/>
+                  <a:srgbClr val="D6E2F0"/>
                 </a:solidFill>
                 <a:latin typeface="Lato"/>
               </a:rPr>
@@ -4316,7 +4316,7 @@
             <a:r>
               <a:rPr sz="1300" b="0" i="0">
                 <a:solidFill>
-                  <a:srgbClr val="7A828F"/>
+                  <a:srgbClr val="D6E2F0"/>
                 </a:solidFill>
                 <a:latin typeface="Lato"/>
               </a:rPr>
@@ -4376,7 +4376,7 @@
         <p:spPr>
           <a:xfrm>
             <a:off x="9098280" y="3246120"/>
-            <a:ext cx="2834640" cy="914400"/>
+            <a:ext cx="2834640" cy="822960"/>
           </a:xfrm>
           <a:prstGeom prst="rect">
             <a:avLst/>
@@ -4400,11 +4400,11 @@
             <a:r>
               <a:rPr sz="1500" b="0" i="0">
                 <a:solidFill>
-                  <a:srgbClr val="F6F1E9"/>
+                  <a:srgbClr val="FFFFFF"/>
                 </a:solidFill>
                 <a:latin typeface="Lato"/>
               </a:rPr>
-              <a:t>de beca sobre el programa completo, a nombre del fondo</a:t>
+              <a:t>de beca, a nombre del fondo</a:t>
             </a:r>
           </a:p>
         </p:txBody>
@@ -4442,7 +4442,7 @@
             <a:r>
               <a:rPr sz="7200" b="0" i="0">
                 <a:solidFill>
-                  <a:srgbClr val="F6F1E9"/>
+                  <a:srgbClr val="FFFFFF"/>
                 </a:solidFill>
                 <a:latin typeface="Oswald"/>
               </a:rPr>
@@ -4484,11 +4484,11 @@
             <a:r>
               <a:rPr sz="1500" b="0" i="0">
                 <a:solidFill>
-                  <a:srgbClr val="F6F1E9"/>
+                  <a:srgbClr val="FFFFFF"/>
                 </a:solidFill>
                 <a:latin typeface="Lato"/>
               </a:rPr>
-              <a:t>de costo para el fondo. Una hoja, 12 meses.</a:t>
+              <a:t>para el fondo. Una hoja, 12 meses.</a:t>
             </a:r>
           </a:p>
         </p:txBody>
@@ -4526,7 +4526,7 @@
             <a:avLst/>
           </a:prstGeom>
           <a:solidFill>
-            <a:srgbClr val="F6F1E9"/>
+            <a:srgbClr val="F7F3EC"/>
           </a:solidFill>
           <a:ln>
             <a:noFill/>
@@ -4572,7 +4572,7 @@
             </a:avLst>
           </a:prstGeom>
           <a:solidFill>
-            <a:srgbClr val="0F1B2D"/>
+            <a:srgbClr val="2B5A8C"/>
           </a:solidFill>
           <a:ln>
             <a:noFill/>
@@ -4675,7 +4675,7 @@
         </p:nvSpPr>
         <p:spPr>
           <a:xfrm>
-            <a:off x="548640" y="1234440"/>
+            <a:off x="548640" y="1280160"/>
             <a:ext cx="7315200" cy="320040"/>
           </a:xfrm>
           <a:prstGeom prst="rect">
@@ -4717,8 +4717,8 @@
         </p:nvSpPr>
         <p:spPr>
           <a:xfrm>
-            <a:off x="548640" y="1554480"/>
-            <a:ext cx="10058400" cy="1737360"/>
+            <a:off x="548640" y="1600200"/>
+            <a:ext cx="10515600" cy="1645920"/>
           </a:xfrm>
           <a:prstGeom prst="rect">
             <a:avLst/>
@@ -4740,13 +4740,13 @@
               </a:spcAft>
             </a:pPr>
             <a:r>
-              <a:rPr sz="3400" b="1" i="0">
-                <a:solidFill>
-                  <a:srgbClr val="0F1B2D"/>
+              <a:rPr sz="3600" b="1" i="0">
+                <a:solidFill>
+                  <a:srgbClr val="1E3A5F"/>
                 </a:solidFill>
                 <a:latin typeface="Lato Black"/>
               </a:rPr>
-              <a:t>Una academia presencial de Bucaramanga que responde por el resultado.</a:t>
+              <a:t>Una academia de Bucaramanga que responde por el resultado.</a:t>
             </a:r>
           </a:p>
         </p:txBody>
@@ -4802,7 +4802,7 @@
         <p:spPr>
           <a:xfrm>
             <a:off x="548640" y="3429000"/>
-            <a:ext cx="2651760" cy="2606040"/>
+            <a:ext cx="2651760" cy="2377440"/>
           </a:xfrm>
           <a:prstGeom prst="roundRect">
             <a:avLst>
@@ -4814,7 +4814,7 @@
           </a:solidFill>
           <a:ln w="9525">
             <a:solidFill>
-              <a:srgbClr val="E3DBCF"/>
+              <a:srgbClr val="DDE4EE"/>
             </a:solidFill>
           </a:ln>
           <a:effectLst/>
@@ -4916,9 +4916,9 @@
               </a:spcAft>
             </a:pPr>
             <a:r>
-              <a:rPr sz="4400" b="0" i="0">
-                <a:solidFill>
-                  <a:srgbClr val="0F1B2D"/>
+              <a:rPr sz="4600" b="0" i="0">
+                <a:solidFill>
+                  <a:srgbClr val="1E3A5F"/>
                 </a:solidFill>
                 <a:latin typeface="Oswald"/>
               </a:rPr>
@@ -4935,8 +4935,8 @@
         </p:nvSpPr>
         <p:spPr>
           <a:xfrm>
-            <a:off x="822960" y="4846320"/>
-            <a:ext cx="2148840" cy="1143000"/>
+            <a:off x="822960" y="4892040"/>
+            <a:ext cx="2148840" cy="822960"/>
           </a:xfrm>
           <a:prstGeom prst="rect">
             <a:avLst/>
@@ -4958,13 +4958,13 @@
               </a:spcAft>
             </a:pPr>
             <a:r>
-              <a:rPr sz="1300" b="0" i="0">
+              <a:rPr sz="1400" b="0" i="0">
                 <a:solidFill>
                   <a:srgbClr val="2B3445"/>
                 </a:solidFill>
                 <a:latin typeface="Lato"/>
               </a:rPr>
-              <a:t>Licencia de la Secretaría de Educación desde 2012. Sede propia en Sotomayor.</a:t>
+              <a:t>Licencia de la Secretaría de Educación</a:t>
             </a:r>
           </a:p>
         </p:txBody>
@@ -4978,7 +4978,7 @@
         <p:spPr>
           <a:xfrm>
             <a:off x="3383280" y="3429000"/>
-            <a:ext cx="2651760" cy="2606040"/>
+            <a:ext cx="2651760" cy="2377440"/>
           </a:xfrm>
           <a:prstGeom prst="roundRect">
             <a:avLst>
@@ -4990,7 +4990,7 @@
           </a:solidFill>
           <a:ln w="9525">
             <a:solidFill>
-              <a:srgbClr val="E3DBCF"/>
+              <a:srgbClr val="DDE4EE"/>
             </a:solidFill>
           </a:ln>
           <a:effectLst/>
@@ -5092,9 +5092,9 @@
               </a:spcAft>
             </a:pPr>
             <a:r>
-              <a:rPr sz="4400" b="0" i="0">
-                <a:solidFill>
-                  <a:srgbClr val="0F1B2D"/>
+              <a:rPr sz="4600" b="0" i="0">
+                <a:solidFill>
+                  <a:srgbClr val="1E3A5F"/>
                 </a:solidFill>
                 <a:latin typeface="Oswald"/>
               </a:rPr>
@@ -5111,8 +5111,8 @@
         </p:nvSpPr>
         <p:spPr>
           <a:xfrm>
-            <a:off x="3657600" y="4846320"/>
-            <a:ext cx="2148840" cy="1143000"/>
+            <a:off x="3657600" y="4892040"/>
+            <a:ext cx="2148840" cy="822960"/>
           </a:xfrm>
           <a:prstGeom prst="rect">
             <a:avLst/>
@@ -5134,13 +5134,13 @@
               </a:spcAft>
             </a:pPr>
             <a:r>
-              <a:rPr sz="1300" b="0" i="0">
+              <a:rPr sz="1400" b="0" i="0">
                 <a:solidFill>
                   <a:srgbClr val="2B3445"/>
                 </a:solidFill>
                 <a:latin typeface="Lato"/>
               </a:rPr>
-              <a:t>Certificación de calidad ISO 9001 e ICONTEC.</a:t>
+              <a:t>Certificación ISO e ICONTEC</a:t>
             </a:r>
           </a:p>
         </p:txBody>
@@ -5154,7 +5154,7 @@
         <p:spPr>
           <a:xfrm>
             <a:off x="6217920" y="3429000"/>
-            <a:ext cx="2651760" cy="2606040"/>
+            <a:ext cx="2651760" cy="2377440"/>
           </a:xfrm>
           <a:prstGeom prst="roundRect">
             <a:avLst>
@@ -5166,7 +5166,7 @@
           </a:solidFill>
           <a:ln w="9525">
             <a:solidFill>
-              <a:srgbClr val="E3DBCF"/>
+              <a:srgbClr val="DDE4EE"/>
             </a:solidFill>
           </a:ln>
           <a:effectLst/>
@@ -5268,9 +5268,9 @@
               </a:spcAft>
             </a:pPr>
             <a:r>
-              <a:rPr sz="4400" b="0" i="0">
-                <a:solidFill>
-                  <a:srgbClr val="0F1B2D"/>
+              <a:rPr sz="4600" b="0" i="0">
+                <a:solidFill>
+                  <a:srgbClr val="1E3A5F"/>
                 </a:solidFill>
                 <a:latin typeface="Oswald"/>
               </a:rPr>
@@ -5287,8 +5287,8 @@
         </p:nvSpPr>
         <p:spPr>
           <a:xfrm>
-            <a:off x="6492240" y="4846320"/>
-            <a:ext cx="2148840" cy="1143000"/>
+            <a:off x="6492240" y="4892040"/>
+            <a:ext cx="2148840" cy="822960"/>
           </a:xfrm>
           <a:prstGeom prst="rect">
             <a:avLst/>
@@ -5310,13 +5310,13 @@
               </a:spcAft>
             </a:pPr>
             <a:r>
-              <a:rPr sz="1300" b="0" i="0">
+              <a:rPr sz="1400" b="0" i="0">
                 <a:solidFill>
                   <a:srgbClr val="2B3445"/>
                 </a:solidFill>
                 <a:latin typeface="Lato"/>
               </a:rPr>
-              <a:t>Un solo programa, completo: de A1 a B2, presencial, en grupos de máximo 16.</a:t>
+              <a:t>De A1 a B2, presencial, grupos de 16</a:t>
             </a:r>
           </a:p>
         </p:txBody>
@@ -5330,7 +5330,7 @@
         <p:spPr>
           <a:xfrm>
             <a:off x="9052560" y="3429000"/>
-            <a:ext cx="2651760" cy="2606040"/>
+            <a:ext cx="2651760" cy="2377440"/>
           </a:xfrm>
           <a:prstGeom prst="roundRect">
             <a:avLst>
@@ -5342,7 +5342,7 @@
           </a:solidFill>
           <a:ln w="9525">
             <a:solidFill>
-              <a:srgbClr val="E3DBCF"/>
+              <a:srgbClr val="DDE4EE"/>
             </a:solidFill>
           </a:ln>
           <a:effectLst/>
@@ -5444,9 +5444,9 @@
               </a:spcAft>
             </a:pPr>
             <a:r>
-              <a:rPr sz="4400" b="0" i="0">
-                <a:solidFill>
-                  <a:srgbClr val="0F1B2D"/>
+              <a:rPr sz="4600" b="0" i="0">
+                <a:solidFill>
+                  <a:srgbClr val="1E3A5F"/>
                 </a:solidFill>
                 <a:latin typeface="Oswald"/>
               </a:rPr>
@@ -5463,8 +5463,8 @@
         </p:nvSpPr>
         <p:spPr>
           <a:xfrm>
-            <a:off x="9326880" y="4846320"/>
-            <a:ext cx="2148840" cy="1143000"/>
+            <a:off x="9326880" y="4892040"/>
+            <a:ext cx="2148840" cy="822960"/>
           </a:xfrm>
           <a:prstGeom prst="rect">
             <a:avLst/>
@@ -5486,13 +5486,13 @@
               </a:spcAft>
             </a:pPr>
             <a:r>
-              <a:rPr sz="1300" b="0" i="0">
+              <a:rPr sz="1400" b="0" i="0">
                 <a:solidFill>
                   <a:srgbClr val="2B3445"/>
                 </a:solidFill>
                 <a:latin typeface="Lato"/>
               </a:rPr>
-              <a:t>Nuestro logro: la garantía por escrito. Si el estudiante cumple y no avanza, le devolvemos el 100% del nivel.</a:t>
+              <a:t>Garantía por escrito: devolvemos el nivel</a:t>
             </a:r>
           </a:p>
         </p:txBody>
@@ -5530,7 +5530,7 @@
             <a:avLst/>
           </a:prstGeom>
           <a:solidFill>
-            <a:srgbClr val="F6F1E9"/>
+            <a:srgbClr val="F7F3EC"/>
           </a:solidFill>
           <a:ln>
             <a:noFill/>
@@ -5576,7 +5576,7 @@
             </a:avLst>
           </a:prstGeom>
           <a:solidFill>
-            <a:srgbClr val="0F1B2D"/>
+            <a:srgbClr val="2B5A8C"/>
           </a:solidFill>
           <a:ln>
             <a:noFill/>
@@ -5679,7 +5679,7 @@
         </p:nvSpPr>
         <p:spPr>
           <a:xfrm>
-            <a:off x="548640" y="1234440"/>
+            <a:off x="548640" y="1280160"/>
             <a:ext cx="7315200" cy="320040"/>
           </a:xfrm>
           <a:prstGeom prst="rect">
@@ -5721,8 +5721,8 @@
         </p:nvSpPr>
         <p:spPr>
           <a:xfrm>
-            <a:off x="548640" y="1554480"/>
-            <a:ext cx="10058400" cy="1737360"/>
+            <a:off x="548640" y="1600200"/>
+            <a:ext cx="10515600" cy="1645920"/>
           </a:xfrm>
           <a:prstGeom prst="rect">
             <a:avLst/>
@@ -5744,13 +5744,13 @@
               </a:spcAft>
             </a:pPr>
             <a:r>
-              <a:rPr sz="3400" b="1" i="0">
-                <a:solidFill>
-                  <a:srgbClr val="0F1B2D"/>
+              <a:rPr sz="3600" b="1" i="0">
+                <a:solidFill>
+                  <a:srgbClr val="1E3A5F"/>
                 </a:solidFill>
                 <a:latin typeface="Lato Black"/>
               </a:rPr>
-              <a:t>Programa completo de inglés, de A1 a B2: 575 horas presenciales.</a:t>
+              <a:t>Programa completo de A1 a B2: 575 horas presenciales.</a:t>
             </a:r>
           </a:p>
         </p:txBody>
@@ -5805,7 +5805,7 @@
         </p:nvSpPr>
         <p:spPr>
           <a:xfrm>
-            <a:off x="548640" y="3246120"/>
+            <a:off x="548640" y="3383280"/>
             <a:ext cx="457200" cy="30000"/>
           </a:xfrm>
           <a:prstGeom prst="rect">
@@ -5849,7 +5849,7 @@
         </p:nvSpPr>
         <p:spPr>
           <a:xfrm>
-            <a:off x="548640" y="3355848"/>
+            <a:off x="548640" y="3493008"/>
             <a:ext cx="3474720" cy="320040"/>
           </a:xfrm>
           <a:prstGeom prst="rect">
@@ -5874,7 +5874,7 @@
             <a:r>
               <a:rPr sz="1100" b="1" i="0" spc="200">
                 <a:solidFill>
-                  <a:srgbClr val="0F1B2D"/>
+                  <a:srgbClr val="1E3A5F"/>
                 </a:solidFill>
                 <a:latin typeface="Lato"/>
               </a:rPr>
@@ -5891,94 +5891,8 @@
         </p:nvSpPr>
         <p:spPr>
           <a:xfrm>
-            <a:off x="548640" y="3675888"/>
-            <a:ext cx="3474720" cy="1097280"/>
-          </a:xfrm>
-          <a:prstGeom prst="rect">
-            <a:avLst/>
-          </a:prstGeom>
-          <a:noFill/>
-        </p:spPr>
-        <p:txBody>
-          <a:bodyPr wrap="square" lIns="45720" rIns="45720" tIns="27432" bIns="27432" anchor="t">
-            <a:spAutoFit/>
-          </a:bodyPr>
-          <a:lstStyle/>
-          <a:p>
-            <a:pPr algn="l">
-              <a:lnSpc>
-                <a:spcPct val="120000"/>
-              </a:lnSpc>
-              <a:spcAft>
-                <a:spcPts val="0"/>
-              </a:spcAft>
-            </a:pPr>
-            <a:r>
-              <a:rPr sz="1250" b="0" i="0">
-                <a:solidFill>
-                  <a:srgbClr val="2B3445"/>
-                </a:solidFill>
-                <a:latin typeface="Lato"/>
-              </a:rPr>
-              <a:t>Mañana 8:00 a 12:00 · Noche 6:30 a 8:30 p. m. · Sábados 8:00 a 12:00. Con 8 o más afiliados, el horario lo define el fondo.</a:t>
-            </a:r>
-          </a:p>
-        </p:txBody>
-      </p:sp>
-      <p:sp>
-        <p:nvSpPr>
-          <p:cNvPr id="12" name="Rectangle 11"/>
-          <p:cNvSpPr/>
-          <p:nvPr/>
-        </p:nvSpPr>
-        <p:spPr>
-          <a:xfrm>
-            <a:off x="4297679" y="3246120"/>
-            <a:ext cx="457200" cy="30000"/>
-          </a:xfrm>
-          <a:prstGeom prst="rect">
-            <a:avLst/>
-          </a:prstGeom>
-          <a:solidFill>
-            <a:srgbClr val="E54C09"/>
-          </a:solidFill>
-          <a:ln>
-            <a:noFill/>
-          </a:ln>
-          <a:effectLst/>
-        </p:spPr>
-        <p:style>
-          <a:lnRef idx="1">
-            <a:schemeClr val="accent1"/>
-          </a:lnRef>
-          <a:fillRef idx="3">
-            <a:schemeClr val="accent1"/>
-          </a:fillRef>
-          <a:effectRef idx="2">
-            <a:schemeClr val="accent1"/>
-          </a:effectRef>
-          <a:fontRef idx="minor">
-            <a:schemeClr val="lt1"/>
-          </a:fontRef>
-        </p:style>
-        <p:txBody>
-          <a:bodyPr rtlCol="0" anchor="ctr"/>
-          <a:lstStyle/>
-          <a:p>
-            <a:pPr algn="ctr"/>
-          </a:p>
-        </p:txBody>
-      </p:sp>
-      <p:sp>
-        <p:nvSpPr>
-          <p:cNvPr id="13" name="TextBox 12"/>
-          <p:cNvSpPr txBox="1"/>
-          <p:nvPr/>
-        </p:nvSpPr>
-        <p:spPr>
-          <a:xfrm>
-            <a:off x="4297679" y="3355848"/>
-            <a:ext cx="3474720" cy="320040"/>
+            <a:off x="548640" y="3813048"/>
+            <a:ext cx="3474720" cy="822960"/>
           </a:xfrm>
           <a:prstGeom prst="rect">
             <a:avLst/>
@@ -6000,68 +5914,26 @@
               </a:spcAft>
             </a:pPr>
             <a:r>
-              <a:rPr sz="1100" b="1" i="0" spc="200">
-                <a:solidFill>
-                  <a:srgbClr val="0F1B2D"/>
+              <a:rPr sz="1700" b="0" i="0">
+                <a:solidFill>
+                  <a:srgbClr val="2B3445"/>
                 </a:solidFill>
                 <a:latin typeface="Lato"/>
               </a:rPr>
-              <a:t>INTENSIDAD</a:t>
-            </a:r>
-          </a:p>
-        </p:txBody>
-      </p:sp>
-      <p:sp>
-        <p:nvSpPr>
-          <p:cNvPr id="14" name="TextBox 13"/>
-          <p:cNvSpPr txBox="1"/>
-          <p:nvPr/>
-        </p:nvSpPr>
-        <p:spPr>
-          <a:xfrm>
-            <a:off x="4297679" y="3675888"/>
-            <a:ext cx="3474720" cy="1097280"/>
-          </a:xfrm>
-          <a:prstGeom prst="rect">
-            <a:avLst/>
-          </a:prstGeom>
-          <a:noFill/>
-        </p:spPr>
-        <p:txBody>
-          <a:bodyPr wrap="square" lIns="45720" rIns="45720" tIns="27432" bIns="27432" anchor="t">
-            <a:spAutoFit/>
-          </a:bodyPr>
-          <a:lstStyle/>
-          <a:p>
-            <a:pPr algn="l">
-              <a:lnSpc>
-                <a:spcPct val="120000"/>
-              </a:lnSpc>
-              <a:spcAft>
-                <a:spcPts val="0"/>
-              </a:spcAft>
-            </a:pPr>
-            <a:r>
-              <a:rPr sz="1250" b="0" i="0">
-                <a:solidFill>
-                  <a:srgbClr val="2B3445"/>
-                </a:solidFill>
-                <a:latin typeface="Lato"/>
-              </a:rPr>
-              <a:t>20 h por semana (unos 7 meses) o 10 h por semana (unos 14 meses). Más un video corto en inglés cada día.</a:t>
-            </a:r>
-          </a:p>
-        </p:txBody>
-      </p:sp>
-      <p:sp>
-        <p:nvSpPr>
-          <p:cNvPr id="15" name="Rectangle 14"/>
+              <a:t>Mañana, noche o sábados</a:t>
+            </a:r>
+          </a:p>
+        </p:txBody>
+      </p:sp>
+      <p:sp>
+        <p:nvSpPr>
+          <p:cNvPr id="12" name="Rectangle 11"/>
           <p:cNvSpPr/>
           <p:nvPr/>
         </p:nvSpPr>
         <p:spPr>
           <a:xfrm>
-            <a:off x="8046718" y="3246120"/>
+            <a:off x="4297679" y="3383280"/>
             <a:ext cx="457200" cy="30000"/>
           </a:xfrm>
           <a:prstGeom prst="rect">
@@ -6099,13 +5971,13 @@
       </p:sp>
       <p:sp>
         <p:nvSpPr>
-          <p:cNvPr id="16" name="TextBox 15"/>
+          <p:cNvPr id="13" name="TextBox 12"/>
           <p:cNvSpPr txBox="1"/>
           <p:nvPr/>
         </p:nvSpPr>
         <p:spPr>
           <a:xfrm>
-            <a:off x="8046718" y="3355848"/>
+            <a:off x="4297679" y="3493008"/>
             <a:ext cx="3474720" cy="320040"/>
           </a:xfrm>
           <a:prstGeom prst="rect">
@@ -6130,111 +6002,25 @@
             <a:r>
               <a:rPr sz="1100" b="1" i="0" spc="200">
                 <a:solidFill>
-                  <a:srgbClr val="0F1B2D"/>
+                  <a:srgbClr val="1E3A5F"/>
                 </a:solidFill>
                 <a:latin typeface="Lato"/>
               </a:rPr>
-              <a:t>DOCENTES</a:t>
-            </a:r>
-          </a:p>
-        </p:txBody>
-      </p:sp>
-      <p:sp>
-        <p:nvSpPr>
-          <p:cNvPr id="17" name="TextBox 16"/>
+              <a:t>INTENSIDAD</a:t>
+            </a:r>
+          </a:p>
+        </p:txBody>
+      </p:sp>
+      <p:sp>
+        <p:nvSpPr>
+          <p:cNvPr id="14" name="TextBox 13"/>
           <p:cNvSpPr txBox="1"/>
           <p:nvPr/>
         </p:nvSpPr>
         <p:spPr>
           <a:xfrm>
-            <a:off x="8046718" y="3675888"/>
-            <a:ext cx="3474720" cy="1097280"/>
-          </a:xfrm>
-          <a:prstGeom prst="rect">
-            <a:avLst/>
-          </a:prstGeom>
-          <a:noFill/>
-        </p:spPr>
-        <p:txBody>
-          <a:bodyPr wrap="square" lIns="45720" rIns="45720" tIns="27432" bIns="27432" anchor="t">
-            <a:spAutoFit/>
-          </a:bodyPr>
-          <a:lstStyle/>
-          <a:p>
-            <a:pPr algn="l">
-              <a:lnSpc>
-                <a:spcPct val="120000"/>
-              </a:lnSpc>
-              <a:spcAft>
-                <a:spcPts val="0"/>
-              </a:spcAft>
-            </a:pPr>
-            <a:r>
-              <a:rPr sz="1250" b="0" i="0">
-                <a:solidFill>
-                  <a:srgbClr val="2B3445"/>
-                </a:solidFill>
-                <a:latin typeface="Lato"/>
-              </a:rPr>
-              <a:t>Profesores bilingües colombianos, uno por grupo de máximo 16, que trabajan como coach y corrigen en el momento.</a:t>
-            </a:r>
-          </a:p>
-        </p:txBody>
-      </p:sp>
-      <p:sp>
-        <p:nvSpPr>
-          <p:cNvPr id="18" name="Rectangle 17"/>
-          <p:cNvSpPr/>
-          <p:nvPr/>
-        </p:nvSpPr>
-        <p:spPr>
-          <a:xfrm>
-            <a:off x="548640" y="4800600"/>
-            <a:ext cx="457200" cy="30000"/>
-          </a:xfrm>
-          <a:prstGeom prst="rect">
-            <a:avLst/>
-          </a:prstGeom>
-          <a:solidFill>
-            <a:srgbClr val="E54C09"/>
-          </a:solidFill>
-          <a:ln>
-            <a:noFill/>
-          </a:ln>
-          <a:effectLst/>
-        </p:spPr>
-        <p:style>
-          <a:lnRef idx="1">
-            <a:schemeClr val="accent1"/>
-          </a:lnRef>
-          <a:fillRef idx="3">
-            <a:schemeClr val="accent1"/>
-          </a:fillRef>
-          <a:effectRef idx="2">
-            <a:schemeClr val="accent1"/>
-          </a:effectRef>
-          <a:fontRef idx="minor">
-            <a:schemeClr val="lt1"/>
-          </a:fontRef>
-        </p:style>
-        <p:txBody>
-          <a:bodyPr rtlCol="0" anchor="ctr"/>
-          <a:lstStyle/>
-          <a:p>
-            <a:pPr algn="ctr"/>
-          </a:p>
-        </p:txBody>
-      </p:sp>
-      <p:sp>
-        <p:nvSpPr>
-          <p:cNvPr id="19" name="TextBox 18"/>
-          <p:cNvSpPr txBox="1"/>
-          <p:nvPr/>
-        </p:nvSpPr>
-        <p:spPr>
-          <a:xfrm>
-            <a:off x="548640" y="4910328"/>
-            <a:ext cx="3474720" cy="320040"/>
+            <a:off x="4297679" y="3813048"/>
+            <a:ext cx="3474720" cy="822960"/>
           </a:xfrm>
           <a:prstGeom prst="rect">
             <a:avLst/>
@@ -6256,68 +6042,26 @@
               </a:spcAft>
             </a:pPr>
             <a:r>
-              <a:rPr sz="1100" b="1" i="0" spc="200">
-                <a:solidFill>
-                  <a:srgbClr val="0F1B2D"/>
+              <a:rPr sz="1700" b="0" i="0">
+                <a:solidFill>
+                  <a:srgbClr val="2B3445"/>
                 </a:solidFill>
                 <a:latin typeface="Lato"/>
               </a:rPr>
-              <a:t>EVALUACIÓN</a:t>
-            </a:r>
-          </a:p>
-        </p:txBody>
-      </p:sp>
-      <p:sp>
-        <p:nvSpPr>
-          <p:cNvPr id="20" name="TextBox 19"/>
-          <p:cNvSpPr txBox="1"/>
-          <p:nvPr/>
-        </p:nvSpPr>
-        <p:spPr>
-          <a:xfrm>
-            <a:off x="548640" y="5230368"/>
-            <a:ext cx="3474720" cy="1097280"/>
-          </a:xfrm>
-          <a:prstGeom prst="rect">
-            <a:avLst/>
-          </a:prstGeom>
-          <a:noFill/>
-        </p:spPr>
-        <p:txBody>
-          <a:bodyPr wrap="square" lIns="45720" rIns="45720" tIns="27432" bIns="27432" anchor="t">
-            <a:spAutoFit/>
-          </a:bodyPr>
-          <a:lstStyle/>
-          <a:p>
-            <a:pPr algn="l">
-              <a:lnSpc>
-                <a:spcPct val="120000"/>
-              </a:lnSpc>
-              <a:spcAft>
-                <a:spcPts val="0"/>
-              </a:spcAft>
-            </a:pPr>
-            <a:r>
-              <a:rPr sz="1250" b="0" i="0">
-                <a:solidFill>
-                  <a:srgbClr val="2B3445"/>
-                </a:solidFill>
-                <a:latin typeface="Lato"/>
-              </a:rPr>
-              <a:t>Prueba de entrada, evaluaciones por nivel y evaluador externo al cierre. El fondo recibe asistencia y cumplimiento; nunca notas.</a:t>
-            </a:r>
-          </a:p>
-        </p:txBody>
-      </p:sp>
-      <p:sp>
-        <p:nvSpPr>
-          <p:cNvPr id="21" name="Rectangle 20"/>
+              <a:t>20 h o 10 h por semana, más un video diario</a:t>
+            </a:r>
+          </a:p>
+        </p:txBody>
+      </p:sp>
+      <p:sp>
+        <p:nvSpPr>
+          <p:cNvPr id="15" name="Rectangle 14"/>
           <p:cNvSpPr/>
           <p:nvPr/>
         </p:nvSpPr>
         <p:spPr>
           <a:xfrm>
-            <a:off x="4297679" y="4800600"/>
+            <a:off x="8046718" y="3383280"/>
             <a:ext cx="457200" cy="30000"/>
           </a:xfrm>
           <a:prstGeom prst="rect">
@@ -6355,13 +6099,13 @@
       </p:sp>
       <p:sp>
         <p:nvSpPr>
-          <p:cNvPr id="22" name="TextBox 21"/>
+          <p:cNvPr id="16" name="TextBox 15"/>
           <p:cNvSpPr txBox="1"/>
           <p:nvPr/>
         </p:nvSpPr>
         <p:spPr>
           <a:xfrm>
-            <a:off x="4297679" y="4910328"/>
+            <a:off x="8046718" y="3493008"/>
             <a:ext cx="3474720" cy="320040"/>
           </a:xfrm>
           <a:prstGeom prst="rect">
@@ -6386,111 +6130,25 @@
             <a:r>
               <a:rPr sz="1100" b="1" i="0" spc="200">
                 <a:solidFill>
-                  <a:srgbClr val="0F1B2D"/>
+                  <a:srgbClr val="1E3A5F"/>
                 </a:solidFill>
                 <a:latin typeface="Lato"/>
               </a:rPr>
-              <a:t>CERTIFICACIÓN</a:t>
-            </a:r>
-          </a:p>
-        </p:txBody>
-      </p:sp>
-      <p:sp>
-        <p:nvSpPr>
-          <p:cNvPr id="23" name="TextBox 22"/>
+              <a:t>DOCENTES</a:t>
+            </a:r>
+          </a:p>
+        </p:txBody>
+      </p:sp>
+      <p:sp>
+        <p:nvSpPr>
+          <p:cNvPr id="17" name="TextBox 16"/>
           <p:cNvSpPr txBox="1"/>
           <p:nvPr/>
         </p:nvSpPr>
         <p:spPr>
           <a:xfrm>
-            <a:off x="4297679" y="5230368"/>
-            <a:ext cx="3474720" cy="1097280"/>
-          </a:xfrm>
-          <a:prstGeom prst="rect">
-            <a:avLst/>
-          </a:prstGeom>
-          <a:noFill/>
-        </p:spPr>
-        <p:txBody>
-          <a:bodyPr wrap="square" lIns="45720" rIns="45720" tIns="27432" bIns="27432" anchor="t">
-            <a:spAutoFit/>
-          </a:bodyPr>
-          <a:lstStyle/>
-          <a:p>
-            <a:pPr algn="l">
-              <a:lnSpc>
-                <a:spcPct val="120000"/>
-              </a:lnSpc>
-              <a:spcAft>
-                <a:spcPts val="0"/>
-              </a:spcAft>
-            </a:pPr>
-            <a:r>
-              <a:rPr sz="1250" b="0" i="0">
-                <a:solidFill>
-                  <a:srgbClr val="2B3445"/>
-                </a:solidFill>
-                <a:latin typeface="Lato"/>
-              </a:rPr>
-              <a:t>Certificado Heiiu por nivel y por programa completo, según la Secretaría de Educación. Certificado de beca a nombre del fondo.</a:t>
-            </a:r>
-          </a:p>
-        </p:txBody>
-      </p:sp>
-      <p:sp>
-        <p:nvSpPr>
-          <p:cNvPr id="24" name="Rectangle 23"/>
-          <p:cNvSpPr/>
-          <p:nvPr/>
-        </p:nvSpPr>
-        <p:spPr>
-          <a:xfrm>
-            <a:off x="8046718" y="4800600"/>
-            <a:ext cx="457200" cy="30000"/>
-          </a:xfrm>
-          <a:prstGeom prst="rect">
-            <a:avLst/>
-          </a:prstGeom>
-          <a:solidFill>
-            <a:srgbClr val="E54C09"/>
-          </a:solidFill>
-          <a:ln>
-            <a:noFill/>
-          </a:ln>
-          <a:effectLst/>
-        </p:spPr>
-        <p:style>
-          <a:lnRef idx="1">
-            <a:schemeClr val="accent1"/>
-          </a:lnRef>
-          <a:fillRef idx="3">
-            <a:schemeClr val="accent1"/>
-          </a:fillRef>
-          <a:effectRef idx="2">
-            <a:schemeClr val="accent1"/>
-          </a:effectRef>
-          <a:fontRef idx="minor">
-            <a:schemeClr val="lt1"/>
-          </a:fontRef>
-        </p:style>
-        <p:txBody>
-          <a:bodyPr rtlCol="0" anchor="ctr"/>
-          <a:lstStyle/>
-          <a:p>
-            <a:pPr algn="ctr"/>
-          </a:p>
-        </p:txBody>
-      </p:sp>
-      <p:sp>
-        <p:nvSpPr>
-          <p:cNvPr id="25" name="TextBox 24"/>
-          <p:cNvSpPr txBox="1"/>
-          <p:nvPr/>
-        </p:nvSpPr>
-        <p:spPr>
-          <a:xfrm>
-            <a:off x="8046718" y="4910328"/>
-            <a:ext cx="3474720" cy="320040"/>
+            <a:off x="8046718" y="3813048"/>
+            <a:ext cx="3474720" cy="822960"/>
           </a:xfrm>
           <a:prstGeom prst="rect">
             <a:avLst/>
@@ -6512,27 +6170,71 @@
               </a:spcAft>
             </a:pPr>
             <a:r>
-              <a:rPr sz="1100" b="1" i="0" spc="200">
-                <a:solidFill>
-                  <a:srgbClr val="0F1B2D"/>
+              <a:rPr sz="1700" b="0" i="0">
+                <a:solidFill>
+                  <a:srgbClr val="2B3445"/>
                 </a:solidFill>
                 <a:latin typeface="Lato"/>
               </a:rPr>
-              <a:t>GARANTÍA</a:t>
-            </a:r>
-          </a:p>
-        </p:txBody>
-      </p:sp>
-      <p:sp>
-        <p:nvSpPr>
-          <p:cNvPr id="26" name="TextBox 25"/>
+              <a:t>Bilingües, uno por grupo de máximo 16</a:t>
+            </a:r>
+          </a:p>
+        </p:txBody>
+      </p:sp>
+      <p:sp>
+        <p:nvSpPr>
+          <p:cNvPr id="18" name="Rectangle 17"/>
+          <p:cNvSpPr/>
+          <p:nvPr/>
+        </p:nvSpPr>
+        <p:spPr>
+          <a:xfrm>
+            <a:off x="548640" y="4800600"/>
+            <a:ext cx="457200" cy="30000"/>
+          </a:xfrm>
+          <a:prstGeom prst="rect">
+            <a:avLst/>
+          </a:prstGeom>
+          <a:solidFill>
+            <a:srgbClr val="E54C09"/>
+          </a:solidFill>
+          <a:ln>
+            <a:noFill/>
+          </a:ln>
+          <a:effectLst/>
+        </p:spPr>
+        <p:style>
+          <a:lnRef idx="1">
+            <a:schemeClr val="accent1"/>
+          </a:lnRef>
+          <a:fillRef idx="3">
+            <a:schemeClr val="accent1"/>
+          </a:fillRef>
+          <a:effectRef idx="2">
+            <a:schemeClr val="accent1"/>
+          </a:effectRef>
+          <a:fontRef idx="minor">
+            <a:schemeClr val="lt1"/>
+          </a:fontRef>
+        </p:style>
+        <p:txBody>
+          <a:bodyPr rtlCol="0" anchor="ctr"/>
+          <a:lstStyle/>
+          <a:p>
+            <a:pPr algn="ctr"/>
+          </a:p>
+        </p:txBody>
+      </p:sp>
+      <p:sp>
+        <p:nvSpPr>
+          <p:cNvPr id="19" name="TextBox 18"/>
           <p:cNvSpPr txBox="1"/>
           <p:nvPr/>
         </p:nvSpPr>
         <p:spPr>
           <a:xfrm>
-            <a:off x="8046718" y="5230368"/>
-            <a:ext cx="3474720" cy="1097280"/>
+            <a:off x="548640" y="4910328"/>
+            <a:ext cx="3474720" cy="320040"/>
           </a:xfrm>
           <a:prstGeom prst="rect">
             <a:avLst/>
@@ -6547,20 +6249,318 @@
           <a:p>
             <a:pPr algn="l">
               <a:lnSpc>
-                <a:spcPct val="120000"/>
+                <a:spcPct val="115000"/>
               </a:lnSpc>
               <a:spcAft>
                 <a:spcPts val="0"/>
               </a:spcAft>
             </a:pPr>
             <a:r>
-              <a:rPr sz="1250" b="0" i="0">
-                <a:solidFill>
-                  <a:srgbClr val="2B3445"/>
+              <a:rPr sz="1100" b="1" i="0" spc="200">
+                <a:solidFill>
+                  <a:srgbClr val="1E3A5F"/>
                 </a:solidFill>
                 <a:latin typeface="Lato"/>
               </a:rPr>
-              <a:t>Si cumple su parte (asistencia 80%, tareas 90%, evaluaciones) y no avanza, le devolvemos el 100% del nivel. Por escrito.</a:t>
+              <a:t>EVALUACIÓN</a:t>
+            </a:r>
+          </a:p>
+        </p:txBody>
+      </p:sp>
+      <p:sp>
+        <p:nvSpPr>
+          <p:cNvPr id="20" name="TextBox 19"/>
+          <p:cNvSpPr txBox="1"/>
+          <p:nvPr/>
+        </p:nvSpPr>
+        <p:spPr>
+          <a:xfrm>
+            <a:off x="548640" y="5230368"/>
+            <a:ext cx="3474720" cy="822960"/>
+          </a:xfrm>
+          <a:prstGeom prst="rect">
+            <a:avLst/>
+          </a:prstGeom>
+          <a:noFill/>
+        </p:spPr>
+        <p:txBody>
+          <a:bodyPr wrap="square" lIns="45720" rIns="45720" tIns="27432" bIns="27432" anchor="t">
+            <a:spAutoFit/>
+          </a:bodyPr>
+          <a:lstStyle/>
+          <a:p>
+            <a:pPr algn="l">
+              <a:lnSpc>
+                <a:spcPct val="115000"/>
+              </a:lnSpc>
+              <a:spcAft>
+                <a:spcPts val="0"/>
+              </a:spcAft>
+            </a:pPr>
+            <a:r>
+              <a:rPr sz="1700" b="0" i="0">
+                <a:solidFill>
+                  <a:srgbClr val="2B3445"/>
+                </a:solidFill>
+                <a:latin typeface="Lato"/>
+              </a:rPr>
+              <a:t>Entrada, por nivel y evaluador externo</a:t>
+            </a:r>
+          </a:p>
+        </p:txBody>
+      </p:sp>
+      <p:sp>
+        <p:nvSpPr>
+          <p:cNvPr id="21" name="Rectangle 20"/>
+          <p:cNvSpPr/>
+          <p:nvPr/>
+        </p:nvSpPr>
+        <p:spPr>
+          <a:xfrm>
+            <a:off x="4297679" y="4800600"/>
+            <a:ext cx="457200" cy="30000"/>
+          </a:xfrm>
+          <a:prstGeom prst="rect">
+            <a:avLst/>
+          </a:prstGeom>
+          <a:solidFill>
+            <a:srgbClr val="E54C09"/>
+          </a:solidFill>
+          <a:ln>
+            <a:noFill/>
+          </a:ln>
+          <a:effectLst/>
+        </p:spPr>
+        <p:style>
+          <a:lnRef idx="1">
+            <a:schemeClr val="accent1"/>
+          </a:lnRef>
+          <a:fillRef idx="3">
+            <a:schemeClr val="accent1"/>
+          </a:fillRef>
+          <a:effectRef idx="2">
+            <a:schemeClr val="accent1"/>
+          </a:effectRef>
+          <a:fontRef idx="minor">
+            <a:schemeClr val="lt1"/>
+          </a:fontRef>
+        </p:style>
+        <p:txBody>
+          <a:bodyPr rtlCol="0" anchor="ctr"/>
+          <a:lstStyle/>
+          <a:p>
+            <a:pPr algn="ctr"/>
+          </a:p>
+        </p:txBody>
+      </p:sp>
+      <p:sp>
+        <p:nvSpPr>
+          <p:cNvPr id="22" name="TextBox 21"/>
+          <p:cNvSpPr txBox="1"/>
+          <p:nvPr/>
+        </p:nvSpPr>
+        <p:spPr>
+          <a:xfrm>
+            <a:off x="4297679" y="4910328"/>
+            <a:ext cx="3474720" cy="320040"/>
+          </a:xfrm>
+          <a:prstGeom prst="rect">
+            <a:avLst/>
+          </a:prstGeom>
+          <a:noFill/>
+        </p:spPr>
+        <p:txBody>
+          <a:bodyPr wrap="square" lIns="45720" rIns="45720" tIns="27432" bIns="27432" anchor="t">
+            <a:spAutoFit/>
+          </a:bodyPr>
+          <a:lstStyle/>
+          <a:p>
+            <a:pPr algn="l">
+              <a:lnSpc>
+                <a:spcPct val="115000"/>
+              </a:lnSpc>
+              <a:spcAft>
+                <a:spcPts val="0"/>
+              </a:spcAft>
+            </a:pPr>
+            <a:r>
+              <a:rPr sz="1100" b="1" i="0" spc="200">
+                <a:solidFill>
+                  <a:srgbClr val="1E3A5F"/>
+                </a:solidFill>
+                <a:latin typeface="Lato"/>
+              </a:rPr>
+              <a:t>CERTIFICACIÓN</a:t>
+            </a:r>
+          </a:p>
+        </p:txBody>
+      </p:sp>
+      <p:sp>
+        <p:nvSpPr>
+          <p:cNvPr id="23" name="TextBox 22"/>
+          <p:cNvSpPr txBox="1"/>
+          <p:nvPr/>
+        </p:nvSpPr>
+        <p:spPr>
+          <a:xfrm>
+            <a:off x="4297679" y="5230368"/>
+            <a:ext cx="3474720" cy="822960"/>
+          </a:xfrm>
+          <a:prstGeom prst="rect">
+            <a:avLst/>
+          </a:prstGeom>
+          <a:noFill/>
+        </p:spPr>
+        <p:txBody>
+          <a:bodyPr wrap="square" lIns="45720" rIns="45720" tIns="27432" bIns="27432" anchor="t">
+            <a:spAutoFit/>
+          </a:bodyPr>
+          <a:lstStyle/>
+          <a:p>
+            <a:pPr algn="l">
+              <a:lnSpc>
+                <a:spcPct val="115000"/>
+              </a:lnSpc>
+              <a:spcAft>
+                <a:spcPts val="0"/>
+              </a:spcAft>
+            </a:pPr>
+            <a:r>
+              <a:rPr sz="1700" b="0" i="0">
+                <a:solidFill>
+                  <a:srgbClr val="2B3445"/>
+                </a:solidFill>
+                <a:latin typeface="Lato"/>
+              </a:rPr>
+              <a:t>Por nivel y por programa completo</a:t>
+            </a:r>
+          </a:p>
+        </p:txBody>
+      </p:sp>
+      <p:sp>
+        <p:nvSpPr>
+          <p:cNvPr id="24" name="Rectangle 23"/>
+          <p:cNvSpPr/>
+          <p:nvPr/>
+        </p:nvSpPr>
+        <p:spPr>
+          <a:xfrm>
+            <a:off x="8046718" y="4800600"/>
+            <a:ext cx="457200" cy="30000"/>
+          </a:xfrm>
+          <a:prstGeom prst="rect">
+            <a:avLst/>
+          </a:prstGeom>
+          <a:solidFill>
+            <a:srgbClr val="E54C09"/>
+          </a:solidFill>
+          <a:ln>
+            <a:noFill/>
+          </a:ln>
+          <a:effectLst/>
+        </p:spPr>
+        <p:style>
+          <a:lnRef idx="1">
+            <a:schemeClr val="accent1"/>
+          </a:lnRef>
+          <a:fillRef idx="3">
+            <a:schemeClr val="accent1"/>
+          </a:fillRef>
+          <a:effectRef idx="2">
+            <a:schemeClr val="accent1"/>
+          </a:effectRef>
+          <a:fontRef idx="minor">
+            <a:schemeClr val="lt1"/>
+          </a:fontRef>
+        </p:style>
+        <p:txBody>
+          <a:bodyPr rtlCol="0" anchor="ctr"/>
+          <a:lstStyle/>
+          <a:p>
+            <a:pPr algn="ctr"/>
+          </a:p>
+        </p:txBody>
+      </p:sp>
+      <p:sp>
+        <p:nvSpPr>
+          <p:cNvPr id="25" name="TextBox 24"/>
+          <p:cNvSpPr txBox="1"/>
+          <p:nvPr/>
+        </p:nvSpPr>
+        <p:spPr>
+          <a:xfrm>
+            <a:off x="8046718" y="4910328"/>
+            <a:ext cx="3474720" cy="320040"/>
+          </a:xfrm>
+          <a:prstGeom prst="rect">
+            <a:avLst/>
+          </a:prstGeom>
+          <a:noFill/>
+        </p:spPr>
+        <p:txBody>
+          <a:bodyPr wrap="square" lIns="45720" rIns="45720" tIns="27432" bIns="27432" anchor="t">
+            <a:spAutoFit/>
+          </a:bodyPr>
+          <a:lstStyle/>
+          <a:p>
+            <a:pPr algn="l">
+              <a:lnSpc>
+                <a:spcPct val="115000"/>
+              </a:lnSpc>
+              <a:spcAft>
+                <a:spcPts val="0"/>
+              </a:spcAft>
+            </a:pPr>
+            <a:r>
+              <a:rPr sz="1100" b="1" i="0" spc="200">
+                <a:solidFill>
+                  <a:srgbClr val="1E3A5F"/>
+                </a:solidFill>
+                <a:latin typeface="Lato"/>
+              </a:rPr>
+              <a:t>GARANTÍA</a:t>
+            </a:r>
+          </a:p>
+        </p:txBody>
+      </p:sp>
+      <p:sp>
+        <p:nvSpPr>
+          <p:cNvPr id="26" name="TextBox 25"/>
+          <p:cNvSpPr txBox="1"/>
+          <p:nvPr/>
+        </p:nvSpPr>
+        <p:spPr>
+          <a:xfrm>
+            <a:off x="8046718" y="5230368"/>
+            <a:ext cx="3474720" cy="822960"/>
+          </a:xfrm>
+          <a:prstGeom prst="rect">
+            <a:avLst/>
+          </a:prstGeom>
+          <a:noFill/>
+        </p:spPr>
+        <p:txBody>
+          <a:bodyPr wrap="square" lIns="45720" rIns="45720" tIns="27432" bIns="27432" anchor="t">
+            <a:spAutoFit/>
+          </a:bodyPr>
+          <a:lstStyle/>
+          <a:p>
+            <a:pPr algn="l">
+              <a:lnSpc>
+                <a:spcPct val="115000"/>
+              </a:lnSpc>
+              <a:spcAft>
+                <a:spcPts val="0"/>
+              </a:spcAft>
+            </a:pPr>
+            <a:r>
+              <a:rPr sz="1700" b="0" i="0">
+                <a:solidFill>
+                  <a:srgbClr val="2B3445"/>
+                </a:solidFill>
+                <a:latin typeface="Lato"/>
+              </a:rPr>
+              <a:t>Cumple y no avanza: devolvemos el 100%</a:t>
             </a:r>
           </a:p>
         </p:txBody>
@@ -6598,7 +6598,7 @@
             <a:avLst/>
           </a:prstGeom>
           <a:solidFill>
-            <a:srgbClr val="F6F1E9"/>
+            <a:srgbClr val="F7F3EC"/>
           </a:solidFill>
           <a:ln>
             <a:noFill/>
@@ -6644,7 +6644,7 @@
             </a:avLst>
           </a:prstGeom>
           <a:solidFill>
-            <a:srgbClr val="0F1B2D"/>
+            <a:srgbClr val="2B5A8C"/>
           </a:solidFill>
           <a:ln>
             <a:noFill/>
@@ -6747,7 +6747,7 @@
         </p:nvSpPr>
         <p:spPr>
           <a:xfrm>
-            <a:off x="548640" y="1234440"/>
+            <a:off x="548640" y="1280160"/>
             <a:ext cx="7315200" cy="320040"/>
           </a:xfrm>
           <a:prstGeom prst="rect">
@@ -6789,8 +6789,8 @@
         </p:nvSpPr>
         <p:spPr>
           <a:xfrm>
-            <a:off x="548640" y="1554480"/>
-            <a:ext cx="6949440" cy="1737360"/>
+            <a:off x="548640" y="1600200"/>
+            <a:ext cx="7132320" cy="1645920"/>
           </a:xfrm>
           <a:prstGeom prst="rect">
             <a:avLst/>
@@ -6812,9 +6812,9 @@
               </a:spcAft>
             </a:pPr>
             <a:r>
-              <a:rPr sz="3400" b="1" i="0">
-                <a:solidFill>
-                  <a:srgbClr val="0F1B2D"/>
+              <a:rPr sz="3600" b="1" i="0">
+                <a:solidFill>
+                  <a:srgbClr val="1E3A5F"/>
                 </a:solidFill>
                 <a:latin typeface="Lato Black"/>
               </a:rPr>
@@ -6873,8 +6873,8 @@
         </p:nvSpPr>
         <p:spPr>
           <a:xfrm>
-            <a:off x="548640" y="3383280"/>
-            <a:ext cx="7132320" cy="2926080"/>
+            <a:off x="548640" y="3474720"/>
+            <a:ext cx="7132320" cy="2743200"/>
           </a:xfrm>
           <a:prstGeom prst="rect">
             <a:avLst/>
@@ -6889,14 +6889,14 @@
           <a:p>
             <a:pPr algn="l">
               <a:lnSpc>
-                <a:spcPct val="118000"/>
+                <a:spcPct val="120000"/>
               </a:lnSpc>
               <a:spcAft>
-                <a:spcPts val="900"/>
+                <a:spcPts val="1200"/>
               </a:spcAft>
             </a:pPr>
             <a:r>
-              <a:rPr sz="1500" b="1" i="0">
+              <a:rPr sz="2000" b="1" i="0">
                 <a:solidFill>
                   <a:srgbClr val="E54C09"/>
                 </a:solidFill>
@@ -6905,35 +6905,26 @@
               <a:t>—  </a:t>
             </a:r>
             <a:r>
-              <a:rPr sz="1500" b="1" i="0">
+              <a:rPr sz="2000" b="0" i="0">
                 <a:solidFill>
                   <a:srgbClr val="2B3445"/>
                 </a:solidFill>
                 <a:latin typeface="Lato"/>
               </a:rPr>
-              <a:t>De contado: $4.782.800 </a:t>
-            </a:r>
-            <a:r>
-              <a:rPr sz="1500" b="0" i="0">
-                <a:solidFill>
-                  <a:srgbClr val="2B3445"/>
-                </a:solidFill>
-                <a:latin typeface="Lato"/>
-              </a:rPr>
-              <a:t>en lugar de $8.696.000 (beca del 45%). Crédito del fondo o cesantías cuentan como contado.</a:t>
+              <a:t>$4.782.800 de contado, en lugar de $8.696.000.</a:t>
             </a:r>
           </a:p>
           <a:p>
             <a:pPr algn="l">
               <a:lnSpc>
-                <a:spcPct val="118000"/>
+                <a:spcPct val="120000"/>
               </a:lnSpc>
               <a:spcAft>
-                <a:spcPts val="900"/>
+                <a:spcPts val="1200"/>
               </a:spcAft>
             </a:pPr>
             <a:r>
-              <a:rPr sz="1500" b="1" i="0">
+              <a:rPr sz="2000" b="1" i="0">
                 <a:solidFill>
                   <a:srgbClr val="E54C09"/>
                 </a:solidFill>
@@ -6942,35 +6933,26 @@
               <a:t>—  </a:t>
             </a:r>
             <a:r>
-              <a:rPr sz="1500" b="1" i="0">
+              <a:rPr sz="2000" b="0" i="0">
                 <a:solidFill>
                   <a:srgbClr val="2B3445"/>
                 </a:solidFill>
                 <a:latin typeface="Lato"/>
               </a:rPr>
-              <a:t>A cuotas con la academia: $5.565.440 </a:t>
-            </a:r>
-            <a:r>
-              <a:rPr sz="1500" b="0" i="0">
-                <a:solidFill>
-                  <a:srgbClr val="2B3445"/>
-                </a:solidFill>
-                <a:latin typeface="Lato"/>
-              </a:rPr>
-              <a:t>(beca del 36%). Ejemplo: $1.113.088 hoy y 11 cuotas de $452.348.</a:t>
+              <a:t>Crédito del fondo o cesantías cuentan como contado.</a:t>
             </a:r>
           </a:p>
           <a:p>
             <a:pPr algn="l">
               <a:lnSpc>
-                <a:spcPct val="118000"/>
+                <a:spcPct val="120000"/>
               </a:lnSpc>
               <a:spcAft>
-                <a:spcPts val="900"/>
+                <a:spcPts val="1200"/>
               </a:spcAft>
             </a:pPr>
             <a:r>
-              <a:rPr sz="1500" b="1" i="0">
+              <a:rPr sz="2000" b="1" i="0">
                 <a:solidFill>
                   <a:srgbClr val="E54C09"/>
                 </a:solidFill>
@@ -6979,22 +6961,13 @@
               <a:t>—  </a:t>
             </a:r>
             <a:r>
-              <a:rPr sz="1500" b="1" i="0">
+              <a:rPr sz="2000" b="0" i="0">
                 <a:solidFill>
                   <a:srgbClr val="2B3445"/>
                 </a:solidFill>
                 <a:latin typeface="Lato"/>
               </a:rPr>
-              <a:t>Beca con el nombre del fondo: </a:t>
-            </a:r>
-            <a:r>
-              <a:rPr sz="1500" b="0" i="0">
-                <a:solidFill>
-                  <a:srgbClr val="2B3445"/>
-                </a:solidFill>
-                <a:latin typeface="Lato"/>
-              </a:rPr>
-              <a:t>3 afiliados por trimestre reciben el 45% aunque paguen a cuotas, más los libros. Si todos cumplen, suben a 5.</a:t>
+              <a:t>3 becas por trimestre con el nombre del fondo.</a:t>
             </a:r>
           </a:p>
         </p:txBody>
@@ -7007,8 +6980,8 @@
         </p:nvSpPr>
         <p:spPr>
           <a:xfrm>
-            <a:off x="8138160" y="1234440"/>
-            <a:ext cx="3520440" cy="4846320"/>
+            <a:off x="8138160" y="1280160"/>
+            <a:ext cx="3520440" cy="4800600"/>
           </a:xfrm>
           <a:prstGeom prst="roundRect">
             <a:avLst>
@@ -7016,7 +6989,7 @@
             </a:avLst>
           </a:prstGeom>
           <a:solidFill>
-            <a:srgbClr val="0F1B2D"/>
+            <a:srgbClr val="2B5A8C"/>
           </a:solidFill>
           <a:ln>
             <a:noFill/>
@@ -7053,14 +7026,14 @@
         </p:nvSpPr>
         <p:spPr>
           <a:xfrm>
-            <a:off x="8458200" y="1554480"/>
+            <a:off x="8458200" y="1600200"/>
             <a:ext cx="548640" cy="30000"/>
           </a:xfrm>
           <a:prstGeom prst="rect">
             <a:avLst/>
           </a:prstGeom>
           <a:solidFill>
-            <a:srgbClr val="E54C09"/>
+            <a:srgbClr val="FBC900"/>
           </a:solidFill>
           <a:ln>
             <a:noFill/>
@@ -7097,7 +7070,7 @@
         </p:nvSpPr>
         <p:spPr>
           <a:xfrm>
-            <a:off x="8366760" y="1874520"/>
+            <a:off x="8366760" y="1920240"/>
             <a:ext cx="3063240" cy="2194560"/>
           </a:xfrm>
           <a:prstGeom prst="rect">
@@ -7113,7 +7086,7 @@
           <a:p>
             <a:pPr algn="l">
               <a:lnSpc>
-                <a:spcPct val="100000"/>
+                <a:spcPct val="115000"/>
               </a:lnSpc>
               <a:spcAft>
                 <a:spcPts val="0"/>
@@ -7139,7 +7112,7 @@
         </p:nvSpPr>
         <p:spPr>
           <a:xfrm>
-            <a:off x="8458200" y="4160520"/>
+            <a:off x="8458200" y="4206240"/>
             <a:ext cx="2880360" cy="1737360"/>
           </a:xfrm>
           <a:prstGeom prst="rect">
@@ -7164,11 +7137,11 @@
             <a:r>
               <a:rPr sz="1500" b="0" i="0">
                 <a:solidFill>
-                  <a:srgbClr val="F6F1E9"/>
+                  <a:srgbClr val="FFFFFF"/>
                 </a:solidFill>
                 <a:latin typeface="Lato"/>
               </a:rPr>
-              <a:t>menos por afiliado sobre el programa completo. Es beca del Fondo de Becas Heiiu, no un descuento: misma tarifa y misma garantía para todos.</a:t>
+              <a:t>menos por afiliado. Beca, no descuento: misma tarifa y misma garantía para todos.</a:t>
             </a:r>
           </a:p>
         </p:txBody>
@@ -7206,7 +7179,7 @@
             <a:avLst/>
           </a:prstGeom>
           <a:solidFill>
-            <a:srgbClr val="F6F1E9"/>
+            <a:srgbClr val="F7F3EC"/>
           </a:solidFill>
           <a:ln>
             <a:noFill/>
@@ -7252,7 +7225,7 @@
             </a:avLst>
           </a:prstGeom>
           <a:solidFill>
-            <a:srgbClr val="0F1B2D"/>
+            <a:srgbClr val="2B5A8C"/>
           </a:solidFill>
           <a:ln>
             <a:noFill/>
@@ -7355,7 +7328,7 @@
         </p:nvSpPr>
         <p:spPr>
           <a:xfrm>
-            <a:off x="548640" y="1234440"/>
+            <a:off x="548640" y="1280160"/>
             <a:ext cx="7315200" cy="320040"/>
           </a:xfrm>
           <a:prstGeom prst="rect">
@@ -7397,8 +7370,8 @@
         </p:nvSpPr>
         <p:spPr>
           <a:xfrm>
-            <a:off x="548640" y="1554480"/>
-            <a:ext cx="10515600" cy="1737360"/>
+            <a:off x="548640" y="1600200"/>
+            <a:ext cx="10515600" cy="1645920"/>
           </a:xfrm>
           <a:prstGeom prst="rect">
             <a:avLst/>
@@ -7420,13 +7393,13 @@
               </a:spcAft>
             </a:pPr>
             <a:r>
-              <a:rPr sz="3400" b="1" i="0">
-                <a:solidFill>
-                  <a:srgbClr val="0F1B2D"/>
+              <a:rPr sz="3600" b="1" i="0">
+                <a:solidFill>
+                  <a:srgbClr val="1E3A5F"/>
                 </a:solidFill>
                 <a:latin typeface="Lato Black"/>
               </a:rPr>
-              <a:t>El fondo gana un beneficio con su nombre. El afiliado gana un inglés que le sirve.</a:t>
+              <a:t>El fondo gana un beneficio con su nombre. El afiliado, un inglés que le sirve.</a:t>
             </a:r>
           </a:p>
         </p:txBody>
@@ -7481,8 +7454,8 @@
         </p:nvSpPr>
         <p:spPr>
           <a:xfrm>
-            <a:off x="548640" y="3246120"/>
-            <a:ext cx="5394960" cy="3017520"/>
+            <a:off x="548640" y="3383280"/>
+            <a:ext cx="5394960" cy="2697480"/>
           </a:xfrm>
           <a:prstGeom prst="roundRect">
             <a:avLst>
@@ -7494,7 +7467,7 @@
           </a:solidFill>
           <a:ln w="9525">
             <a:solidFill>
-              <a:srgbClr val="E3DBCF"/>
+              <a:srgbClr val="DDE4EE"/>
             </a:solidFill>
           </a:ln>
           <a:effectLst/>
@@ -7529,7 +7502,7 @@
         </p:nvSpPr>
         <p:spPr>
           <a:xfrm>
-            <a:off x="868680" y="3429000"/>
+            <a:off x="868680" y="3566160"/>
             <a:ext cx="4754880" cy="320040"/>
           </a:xfrm>
           <a:prstGeom prst="rect">
@@ -7571,8 +7544,8 @@
         </p:nvSpPr>
         <p:spPr>
           <a:xfrm>
-            <a:off x="822960" y="3794760"/>
-            <a:ext cx="4846320" cy="2468880"/>
+            <a:off x="822960" y="3977639"/>
+            <a:ext cx="4846320" cy="2103120"/>
           </a:xfrm>
           <a:prstGeom prst="rect">
             <a:avLst/>
@@ -7587,14 +7560,14 @@
           <a:p>
             <a:pPr algn="l">
               <a:lnSpc>
-                <a:spcPct val="118000"/>
+                <a:spcPct val="120000"/>
               </a:lnSpc>
               <a:spcAft>
-                <a:spcPts val="600"/>
+                <a:spcPts val="800"/>
               </a:spcAft>
             </a:pPr>
             <a:r>
-              <a:rPr sz="1300" b="1" i="0">
+              <a:rPr sz="1800" b="1" i="0">
                 <a:solidFill>
                   <a:srgbClr val="E54C09"/>
                 </a:solidFill>
@@ -7603,35 +7576,26 @@
               <a:t>—  </a:t>
             </a:r>
             <a:r>
-              <a:rPr sz="1300" b="1" i="0">
+              <a:rPr sz="1800" b="0" i="0">
                 <a:solidFill>
                   <a:srgbClr val="2B3445"/>
                 </a:solidFill>
                 <a:latin typeface="Lato"/>
               </a:rPr>
-              <a:t>Sin costo ni presupuesto. </a:t>
-            </a:r>
-            <a:r>
-              <a:rPr sz="1300" b="0" i="0">
-                <a:solidFill>
-                  <a:srgbClr val="2B3445"/>
-                </a:solidFill>
-                <a:latin typeface="Lato"/>
-              </a:rPr>
-              <a:t>El fondo postula con una carta; no paga ni cobra nada.</a:t>
+              <a:t>Sin costo ni presupuesto</a:t>
             </a:r>
           </a:p>
           <a:p>
             <a:pPr algn="l">
               <a:lnSpc>
-                <a:spcPct val="118000"/>
+                <a:spcPct val="120000"/>
               </a:lnSpc>
               <a:spcAft>
-                <a:spcPts val="600"/>
+                <a:spcPts val="800"/>
               </a:spcAft>
             </a:pPr>
             <a:r>
-              <a:rPr sz="1300" b="1" i="0">
+              <a:rPr sz="1800" b="1" i="0">
                 <a:solidFill>
                   <a:srgbClr val="E54C09"/>
                 </a:solidFill>
@@ -7640,35 +7604,26 @@
               <a:t>—  </a:t>
             </a:r>
             <a:r>
-              <a:rPr sz="1300" b="1" i="0">
+              <a:rPr sz="1800" b="0" i="0">
                 <a:solidFill>
                   <a:srgbClr val="2B3445"/>
                 </a:solidFill>
                 <a:latin typeface="Lato"/>
               </a:rPr>
-              <a:t>Becas y certificados con su nombre, </a:t>
-            </a:r>
-            <a:r>
-              <a:rPr sz="1300" b="0" i="0">
-                <a:solidFill>
-                  <a:srgbClr val="2B3445"/>
-                </a:solidFill>
-                <a:latin typeface="Lato"/>
-              </a:rPr>
-              <a:t>entregados en su propio evento.</a:t>
+              <a:t>Becas y certificados con su nombre</a:t>
             </a:r>
           </a:p>
           <a:p>
             <a:pPr algn="l">
               <a:lnSpc>
-                <a:spcPct val="118000"/>
+                <a:spcPct val="120000"/>
               </a:lnSpc>
               <a:spcAft>
-                <a:spcPts val="600"/>
+                <a:spcPts val="800"/>
               </a:spcAft>
             </a:pPr>
             <a:r>
-              <a:rPr sz="1300" b="1" i="0">
+              <a:rPr sz="1800" b="1" i="0">
                 <a:solidFill>
                   <a:srgbClr val="E54C09"/>
                 </a:solidFill>
@@ -7677,59 +7632,13 @@
               <a:t>—  </a:t>
             </a:r>
             <a:r>
-              <a:rPr sz="1300" b="1" i="0">
+              <a:rPr sz="1800" b="0" i="0">
                 <a:solidFill>
                   <a:srgbClr val="2B3445"/>
                 </a:solidFill>
                 <a:latin typeface="Lato"/>
               </a:rPr>
-              <a:t>Reporte de asistencia y cumplimiento </a:t>
-            </a:r>
-            <a:r>
-              <a:rPr sz="1300" b="0" i="0">
-                <a:solidFill>
-                  <a:srgbClr val="2B3445"/>
-                </a:solidFill>
-                <a:latin typeface="Lato"/>
-              </a:rPr>
-              <a:t>de cada becado: el fondo ve quién cumple.</a:t>
-            </a:r>
-          </a:p>
-          <a:p>
-            <a:pPr algn="l">
-              <a:lnSpc>
-                <a:spcPct val="118000"/>
-              </a:lnSpc>
-              <a:spcAft>
-                <a:spcPts val="600"/>
-              </a:spcAft>
-            </a:pPr>
-            <a:r>
-              <a:rPr sz="1300" b="1" i="0">
-                <a:solidFill>
-                  <a:srgbClr val="E54C09"/>
-                </a:solidFill>
-                <a:latin typeface="Lato"/>
-              </a:rPr>
-              <a:t>—  </a:t>
-            </a:r>
-            <a:r>
-              <a:rPr sz="1300" b="1" i="0">
-                <a:solidFill>
-                  <a:srgbClr val="2B3445"/>
-                </a:solidFill>
-                <a:latin typeface="Lato"/>
-              </a:rPr>
-              <a:t>10 diagnósticos de nivel sin costo </a:t>
-            </a:r>
-            <a:r>
-              <a:rPr sz="1300" b="0" i="0">
-                <a:solidFill>
-                  <a:srgbClr val="2B3445"/>
-                </a:solidFill>
-                <a:latin typeface="Lato"/>
-              </a:rPr>
-              <a:t>la semana siguiente a la firma.</a:t>
+              <a:t>Reporte: ve quién cumple</a:t>
             </a:r>
           </a:p>
         </p:txBody>
@@ -7742,8 +7651,8 @@
         </p:nvSpPr>
         <p:spPr>
           <a:xfrm>
-            <a:off x="6217920" y="3246120"/>
-            <a:ext cx="5394960" cy="3017520"/>
+            <a:off x="6217920" y="3383280"/>
+            <a:ext cx="5394960" cy="2697480"/>
           </a:xfrm>
           <a:prstGeom prst="roundRect">
             <a:avLst>
@@ -7751,7 +7660,7 @@
             </a:avLst>
           </a:prstGeom>
           <a:solidFill>
-            <a:srgbClr val="0F1B2D"/>
+            <a:srgbClr val="2B5A8C"/>
           </a:solidFill>
           <a:ln>
             <a:noFill/>
@@ -7788,7 +7697,7 @@
         </p:nvSpPr>
         <p:spPr>
           <a:xfrm>
-            <a:off x="6537960" y="3429000"/>
+            <a:off x="6537960" y="3566160"/>
             <a:ext cx="4754880" cy="320040"/>
           </a:xfrm>
           <a:prstGeom prst="rect">
@@ -7813,7 +7722,7 @@
             <a:r>
               <a:rPr sz="1100" b="1" i="0" spc="200">
                 <a:solidFill>
-                  <a:srgbClr val="E54C09"/>
+                  <a:srgbClr val="FBC900"/>
                 </a:solidFill>
                 <a:latin typeface="Lato"/>
               </a:rPr>
@@ -7830,8 +7739,8 @@
         </p:nvSpPr>
         <p:spPr>
           <a:xfrm>
-            <a:off x="6492240" y="3794760"/>
-            <a:ext cx="4846320" cy="2468880"/>
+            <a:off x="6492240" y="3977639"/>
+            <a:ext cx="4846320" cy="2103120"/>
           </a:xfrm>
           <a:prstGeom prst="rect">
             <a:avLst/>
@@ -7846,191 +7755,85 @@
           <a:p>
             <a:pPr algn="l">
               <a:lnSpc>
-                <a:spcPct val="118000"/>
+                <a:spcPct val="120000"/>
               </a:lnSpc>
               <a:spcAft>
-                <a:spcPts val="600"/>
+                <a:spcPts val="800"/>
               </a:spcAft>
             </a:pPr>
             <a:r>
-              <a:rPr sz="1300" b="1" i="0">
-                <a:solidFill>
-                  <a:srgbClr val="E54C09"/>
+              <a:rPr sz="1800" b="1" i="0">
+                <a:solidFill>
+                  <a:srgbClr val="FBC900"/>
                 </a:solidFill>
                 <a:latin typeface="Lato"/>
               </a:rPr>
               <a:t>—  </a:t>
             </a:r>
             <a:r>
-              <a:rPr sz="1300" b="1" i="0">
-                <a:solidFill>
-                  <a:srgbClr val="F6F1E9"/>
+              <a:rPr sz="1800" b="0" i="0">
+                <a:solidFill>
+                  <a:srgbClr val="FFFFFF"/>
                 </a:solidFill>
                 <a:latin typeface="Lato"/>
               </a:rPr>
-              <a:t>Paga la mitad, </a:t>
-            </a:r>
-            <a:r>
-              <a:rPr sz="1300" b="0" i="0">
-                <a:solidFill>
-                  <a:srgbClr val="F6F1E9"/>
-                </a:solidFill>
-                <a:latin typeface="Lato"/>
-              </a:rPr>
-              <a:t>y la beca cubre también a su cónyuge y a sus hijos desde los 12 años.</a:t>
+              <a:t>Paga la mitad, también cónyuge e hijos</a:t>
             </a:r>
           </a:p>
           <a:p>
             <a:pPr algn="l">
               <a:lnSpc>
-                <a:spcPct val="118000"/>
+                <a:spcPct val="120000"/>
               </a:lnSpc>
               <a:spcAft>
-                <a:spcPts val="600"/>
+                <a:spcPts val="800"/>
               </a:spcAft>
             </a:pPr>
             <a:r>
-              <a:rPr sz="1300" b="1" i="0">
-                <a:solidFill>
-                  <a:srgbClr val="E54C09"/>
+              <a:rPr sz="1800" b="1" i="0">
+                <a:solidFill>
+                  <a:srgbClr val="FBC900"/>
                 </a:solidFill>
                 <a:latin typeface="Lato"/>
               </a:rPr>
               <a:t>—  </a:t>
             </a:r>
             <a:r>
-              <a:rPr sz="1300" b="1" i="0">
-                <a:solidFill>
-                  <a:srgbClr val="F6F1E9"/>
+              <a:rPr sz="1800" b="0" i="0">
+                <a:solidFill>
+                  <a:srgbClr val="FFFFFF"/>
                 </a:solidFill>
                 <a:latin typeface="Lato"/>
               </a:rPr>
-              <a:t>Gana cerca de un 26% más </a:t>
-            </a:r>
-            <a:r>
-              <a:rPr sz="1300" b="0" i="0">
-                <a:solidFill>
-                  <a:srgbClr val="F6F1E9"/>
-                </a:solidFill>
-                <a:latin typeface="Lato"/>
-              </a:rPr>
-              <a:t>quien certifica su inglés, frente a quien hace el mismo trabajo sin él.¹</a:t>
+              <a:t>Garantía: si cumple y no avanza, 100% de vuelta</a:t>
             </a:r>
           </a:p>
           <a:p>
             <a:pPr algn="l">
               <a:lnSpc>
-                <a:spcPct val="118000"/>
+                <a:spcPct val="120000"/>
               </a:lnSpc>
               <a:spcAft>
-                <a:spcPts val="600"/>
+                <a:spcPts val="800"/>
               </a:spcAft>
             </a:pPr>
             <a:r>
-              <a:rPr sz="1300" b="1" i="0">
-                <a:solidFill>
-                  <a:srgbClr val="E54C09"/>
+              <a:rPr sz="1800" b="1" i="0">
+                <a:solidFill>
+                  <a:srgbClr val="FBC900"/>
                 </a:solidFill>
                 <a:latin typeface="Lato"/>
               </a:rPr>
               <a:t>—  </a:t>
             </a:r>
             <a:r>
-              <a:rPr sz="1300" b="1" i="0">
-                <a:solidFill>
-                  <a:srgbClr val="F6F1E9"/>
+              <a:rPr sz="1800" b="0" i="0">
+                <a:solidFill>
+                  <a:srgbClr val="FFFFFF"/>
                 </a:solidFill>
                 <a:latin typeface="Lato"/>
               </a:rPr>
-              <a:t>Garantía por escrito: </a:t>
-            </a:r>
-            <a:r>
-              <a:rPr sz="1300" b="0" i="0">
-                <a:solidFill>
-                  <a:srgbClr val="F6F1E9"/>
-                </a:solidFill>
-                <a:latin typeface="Lato"/>
-              </a:rPr>
-              <a:t>si cumple y no avanza, recibe el 100% del nivel de vuelta.</a:t>
-            </a:r>
-          </a:p>
-          <a:p>
-            <a:pPr algn="l">
-              <a:lnSpc>
-                <a:spcPct val="118000"/>
-              </a:lnSpc>
-              <a:spcAft>
-                <a:spcPts val="600"/>
-              </a:spcAft>
-            </a:pPr>
-            <a:r>
-              <a:rPr sz="1300" b="1" i="0">
-                <a:solidFill>
-                  <a:srgbClr val="E54C09"/>
-                </a:solidFill>
-                <a:latin typeface="Lato"/>
-              </a:rPr>
-              <a:t>—  </a:t>
-            </a:r>
-            <a:r>
-              <a:rPr sz="1300" b="1" i="0">
-                <a:solidFill>
-                  <a:srgbClr val="F6F1E9"/>
-                </a:solidFill>
-                <a:latin typeface="Lato"/>
-              </a:rPr>
-              <a:t>No entrena solo: </a:t>
-            </a:r>
-            <a:r>
-              <a:rPr sz="1300" b="0" i="0">
-                <a:solidFill>
-                  <a:srgbClr val="F6F1E9"/>
-                </a:solidFill>
-                <a:latin typeface="Lato"/>
-              </a:rPr>
-              <a:t>profesor que corrige ahí mismo, coach que no lo deja rendirse, y el video del primer día junto al del último.</a:t>
-            </a:r>
-          </a:p>
-        </p:txBody>
-      </p:sp>
-      <p:sp>
-        <p:nvSpPr>
-          <p:cNvPr id="15" name="TextBox 14"/>
-          <p:cNvSpPr txBox="1"/>
-          <p:nvPr/>
-        </p:nvSpPr>
-        <p:spPr>
-          <a:xfrm>
-            <a:off x="548640" y="6144768"/>
-            <a:ext cx="10972800" cy="274320"/>
-          </a:xfrm>
-          <a:prstGeom prst="rect">
-            <a:avLst/>
-          </a:prstGeom>
-          <a:noFill/>
-        </p:spPr>
-        <p:txBody>
-          <a:bodyPr wrap="square" lIns="45720" rIns="45720" tIns="27432" bIns="27432" anchor="t">
-            <a:spAutoFit/>
-          </a:bodyPr>
-          <a:lstStyle/>
-          <a:p>
-            <a:pPr algn="l">
-              <a:lnSpc>
-                <a:spcPct val="115000"/>
-              </a:lnSpc>
-              <a:spcAft>
-                <a:spcPts val="0"/>
-              </a:spcAft>
-            </a:pPr>
-            <a:r>
-              <a:rPr sz="900" b="0" i="0">
-                <a:solidFill>
-                  <a:srgbClr val="7A828F"/>
-                </a:solidFill>
-                <a:latin typeface="Lato"/>
-              </a:rPr>
-              <a:t>¹ DNP, Archivos de Economía, Bilingüismo laboral en Colombia.</a:t>
+              <a:t>Nadie entrena solo: coach y video diario</a:t>
             </a:r>
           </a:p>
         </p:txBody>
@@ -8068,7 +7871,7 @@
             <a:avLst/>
           </a:prstGeom>
           <a:solidFill>
-            <a:srgbClr val="0F1B2D"/>
+            <a:srgbClr val="2B5A8C"/>
           </a:solidFill>
           <a:ln>
             <a:noFill/>
@@ -8114,7 +7917,7 @@
             </a:avLst>
           </a:prstGeom>
           <a:solidFill>
-            <a:srgbClr val="1B2A41"/>
+            <a:srgbClr val="3D6FA6"/>
           </a:solidFill>
           <a:ln>
             <a:noFill/>
@@ -8200,7 +8003,7 @@
             <a:r>
               <a:rPr sz="1200" b="0" i="0">
                 <a:solidFill>
-                  <a:srgbClr val="9AA4B5"/>
+                  <a:srgbClr val="D6E2F0"/>
                 </a:solidFill>
                 <a:latin typeface="Oswald"/>
               </a:rPr>
@@ -8217,7 +8020,7 @@
         </p:nvSpPr>
         <p:spPr>
           <a:xfrm>
-            <a:off x="548640" y="1234440"/>
+            <a:off x="548640" y="1280160"/>
             <a:ext cx="7315200" cy="320040"/>
           </a:xfrm>
           <a:prstGeom prst="rect">
@@ -8242,7 +8045,7 @@
             <a:r>
               <a:rPr sz="1100" b="1" i="0" spc="250">
                 <a:solidFill>
-                  <a:srgbClr val="E54C09"/>
+                  <a:srgbClr val="FBC900"/>
                 </a:solidFill>
                 <a:latin typeface="Lato"/>
               </a:rPr>
@@ -8259,8 +8062,8 @@
         </p:nvSpPr>
         <p:spPr>
           <a:xfrm>
-            <a:off x="548640" y="1554480"/>
-            <a:ext cx="10515600" cy="1737360"/>
+            <a:off x="548640" y="1600200"/>
+            <a:ext cx="10515600" cy="1645920"/>
           </a:xfrm>
           <a:prstGeom prst="rect">
             <a:avLst/>
@@ -8282,9 +8085,9 @@
               </a:spcAft>
             </a:pPr>
             <a:r>
-              <a:rPr sz="3400" b="1" i="0">
-                <a:solidFill>
-                  <a:srgbClr val="F6F1E9"/>
+              <a:rPr sz="3600" b="1" i="0">
+                <a:solidFill>
+                  <a:srgbClr val="FFFFFF"/>
                 </a:solidFill>
                 <a:latin typeface="Lato Black"/>
               </a:rPr>
@@ -8326,7 +8129,7 @@
             <a:r>
               <a:rPr sz="950" b="0" i="0">
                 <a:solidFill>
-                  <a:srgbClr val="9AA4B5"/>
+                  <a:srgbClr val="D6E2F0"/>
                 </a:solidFill>
                 <a:latin typeface="Lato"/>
               </a:rPr>
@@ -8343,8 +8146,8 @@
         </p:nvSpPr>
         <p:spPr>
           <a:xfrm>
-            <a:off x="548640" y="3246120"/>
-            <a:ext cx="3520440" cy="2834640"/>
+            <a:off x="548640" y="3383280"/>
+            <a:ext cx="3520440" cy="2560320"/>
           </a:xfrm>
           <a:prstGeom prst="roundRect">
             <a:avLst>
@@ -8352,7 +8155,7 @@
             </a:avLst>
           </a:prstGeom>
           <a:solidFill>
-            <a:srgbClr val="1B2A41"/>
+            <a:srgbClr val="3D6FA6"/>
           </a:solidFill>
           <a:ln>
             <a:noFill/>
@@ -8389,7 +8192,7 @@
         </p:nvSpPr>
         <p:spPr>
           <a:xfrm>
-            <a:off x="822960" y="3337560"/>
+            <a:off x="822960" y="3474720"/>
             <a:ext cx="3017520" cy="914400"/>
           </a:xfrm>
           <a:prstGeom prst="rect">
@@ -8412,7 +8215,7 @@
               </a:spcAft>
             </a:pPr>
             <a:r>
-              <a:rPr sz="5000" b="0" i="0">
+              <a:rPr sz="5400" b="0" i="0">
                 <a:solidFill>
                   <a:srgbClr val="FBC900"/>
                 </a:solidFill>
@@ -8431,7 +8234,7 @@
         </p:nvSpPr>
         <p:spPr>
           <a:xfrm>
-            <a:off x="822960" y="4251960"/>
+            <a:off x="822960" y="4434840"/>
             <a:ext cx="3017520" cy="274320"/>
           </a:xfrm>
           <a:prstGeom prst="rect">
@@ -8456,7 +8259,7 @@
             <a:r>
               <a:rPr sz="1050" b="1" i="0" spc="200">
                 <a:solidFill>
-                  <a:srgbClr val="E54C09"/>
+                  <a:srgbClr val="FBC900"/>
                 </a:solidFill>
                 <a:latin typeface="Lato"/>
               </a:rPr>
@@ -8473,8 +8276,8 @@
         </p:nvSpPr>
         <p:spPr>
           <a:xfrm>
-            <a:off x="822960" y="4572000"/>
-            <a:ext cx="3017520" cy="1463040"/>
+            <a:off x="822960" y="4754880"/>
+            <a:ext cx="3017520" cy="1005840"/>
           </a:xfrm>
           <a:prstGeom prst="rect">
             <a:avLst/>
@@ -8496,13 +8299,13 @@
               </a:spcAft>
             </a:pPr>
             <a:r>
-              <a:rPr sz="1300" b="0" i="0">
-                <a:solidFill>
-                  <a:srgbClr val="F6F1E9"/>
+              <a:rPr sz="1700" b="0" i="0">
+                <a:solidFill>
+                  <a:srgbClr val="FFFFFF"/>
                 </a:solidFill>
                 <a:latin typeface="Lato"/>
               </a:rPr>
-              <a:t>Martes 3 de noviembre de 2026. El grupo no para en diciembre: sigue hasta terminar el nivel, solo descansa los festivos.</a:t>
+              <a:t>Y no para en diciembre.</a:t>
             </a:r>
           </a:p>
         </p:txBody>
@@ -8515,8 +8318,8 @@
         </p:nvSpPr>
         <p:spPr>
           <a:xfrm>
-            <a:off x="4297679" y="3246120"/>
-            <a:ext cx="3520440" cy="2834640"/>
+            <a:off x="4297679" y="3383280"/>
+            <a:ext cx="3520440" cy="2560320"/>
           </a:xfrm>
           <a:prstGeom prst="roundRect">
             <a:avLst>
@@ -8524,7 +8327,7 @@
             </a:avLst>
           </a:prstGeom>
           <a:solidFill>
-            <a:srgbClr val="1B2A41"/>
+            <a:srgbClr val="3D6FA6"/>
           </a:solidFill>
           <a:ln>
             <a:noFill/>
@@ -8561,7 +8364,7 @@
         </p:nvSpPr>
         <p:spPr>
           <a:xfrm>
-            <a:off x="4571999" y="3337560"/>
+            <a:off x="4571999" y="3474720"/>
             <a:ext cx="3017520" cy="914400"/>
           </a:xfrm>
           <a:prstGeom prst="rect">
@@ -8584,7 +8387,7 @@
               </a:spcAft>
             </a:pPr>
             <a:r>
-              <a:rPr sz="5000" b="0" i="0">
+              <a:rPr sz="5400" b="0" i="0">
                 <a:solidFill>
                   <a:srgbClr val="FBC900"/>
                 </a:solidFill>
@@ -8603,7 +8406,7 @@
         </p:nvSpPr>
         <p:spPr>
           <a:xfrm>
-            <a:off x="4571999" y="4251960"/>
+            <a:off x="4571999" y="4434840"/>
             <a:ext cx="3017520" cy="274320"/>
           </a:xfrm>
           <a:prstGeom prst="rect">
@@ -8628,7 +8431,7 @@
             <a:r>
               <a:rPr sz="1050" b="1" i="0" spc="200">
                 <a:solidFill>
-                  <a:srgbClr val="E54C09"/>
+                  <a:srgbClr val="FBC900"/>
                 </a:solidFill>
                 <a:latin typeface="Lato"/>
               </a:rPr>
@@ -8645,8 +8448,8 @@
         </p:nvSpPr>
         <p:spPr>
           <a:xfrm>
-            <a:off x="4571999" y="4572000"/>
-            <a:ext cx="3017520" cy="1463040"/>
+            <a:off x="4571999" y="4754880"/>
+            <a:ext cx="3017520" cy="1005840"/>
           </a:xfrm>
           <a:prstGeom prst="rect">
             <a:avLst/>
@@ -8668,13 +8471,13 @@
               </a:spcAft>
             </a:pPr>
             <a:r>
-              <a:rPr sz="1300" b="0" i="0">
-                <a:solidFill>
-                  <a:srgbClr val="F6F1E9"/>
+              <a:rPr sz="1700" b="0" i="0">
+                <a:solidFill>
+                  <a:srgbClr val="FFFFFF"/>
                 </a:solidFill>
                 <a:latin typeface="Lato"/>
               </a:rPr>
-              <a:t>Grupos de máximo 16, por orden de matrícula con la inicial pagada. Los que no entren ahora esperan al siguiente grupo.</a:t>
+              <a:t>Por orden de matrícula.</a:t>
             </a:r>
           </a:p>
         </p:txBody>
@@ -8687,8 +8490,8 @@
         </p:nvSpPr>
         <p:spPr>
           <a:xfrm>
-            <a:off x="8046718" y="3246120"/>
-            <a:ext cx="3520440" cy="2834640"/>
+            <a:off x="8046718" y="3383280"/>
+            <a:ext cx="3520440" cy="2560320"/>
           </a:xfrm>
           <a:prstGeom prst="roundRect">
             <a:avLst>
@@ -8696,7 +8499,7 @@
             </a:avLst>
           </a:prstGeom>
           <a:solidFill>
-            <a:srgbClr val="1B2A41"/>
+            <a:srgbClr val="3D6FA6"/>
           </a:solidFill>
           <a:ln>
             <a:noFill/>
@@ -8733,7 +8536,7 @@
         </p:nvSpPr>
         <p:spPr>
           <a:xfrm>
-            <a:off x="8321038" y="3337560"/>
+            <a:off x="8321038" y="3474720"/>
             <a:ext cx="3017520" cy="914400"/>
           </a:xfrm>
           <a:prstGeom prst="rect">
@@ -8756,7 +8559,7 @@
               </a:spcAft>
             </a:pPr>
             <a:r>
-              <a:rPr sz="5000" b="0" i="0">
+              <a:rPr sz="5400" b="0" i="0">
                 <a:solidFill>
                   <a:srgbClr val="FBC900"/>
                 </a:solidFill>
@@ -8775,7 +8578,7 @@
         </p:nvSpPr>
         <p:spPr>
           <a:xfrm>
-            <a:off x="8321038" y="4251960"/>
+            <a:off x="8321038" y="4434840"/>
             <a:ext cx="3017520" cy="274320"/>
           </a:xfrm>
           <a:prstGeom prst="rect">
@@ -8800,7 +8603,7 @@
             <a:r>
               <a:rPr sz="1050" b="1" i="0" spc="200">
                 <a:solidFill>
-                  <a:srgbClr val="E54C09"/>
+                  <a:srgbClr val="FBC900"/>
                 </a:solidFill>
                 <a:latin typeface="Lato"/>
               </a:rPr>
@@ -8817,8 +8620,8 @@
         </p:nvSpPr>
         <p:spPr>
           <a:xfrm>
-            <a:off x="8321038" y="4572000"/>
-            <a:ext cx="3017520" cy="1463040"/>
+            <a:off x="8321038" y="4754880"/>
+            <a:ext cx="3017520" cy="1005840"/>
           </a:xfrm>
           <a:prstGeom prst="rect">
             <a:avLst/>
@@ -8840,13 +8643,13 @@
               </a:spcAft>
             </a:pPr>
             <a:r>
-              <a:rPr sz="1300" b="0" i="0">
-                <a:solidFill>
-                  <a:srgbClr val="F6F1E9"/>
+              <a:rPr sz="1700" b="0" i="0">
+                <a:solidFill>
+                  <a:srgbClr val="FFFFFF"/>
                 </a:solidFill>
                 <a:latin typeface="Lato"/>
               </a:rPr>
-              <a:t>Este trimestre, para los afiliados que el fondo elija. Si todos cumplen, suben a 5 el siguiente.</a:t>
+              <a:t>Este trimestre. Suben a 5.</a:t>
             </a:r>
           </a:p>
         </p:txBody>
@@ -8884,7 +8687,7 @@
             <a:avLst/>
           </a:prstGeom>
           <a:solidFill>
-            <a:srgbClr val="0F1B2D"/>
+            <a:srgbClr val="2B5A8C"/>
           </a:solidFill>
           <a:ln>
             <a:noFill/>
@@ -8970,7 +8773,7 @@
             <a:r>
               <a:rPr sz="1200" b="0" i="0">
                 <a:solidFill>
-                  <a:srgbClr val="9AA4B5"/>
+                  <a:srgbClr val="D6E2F0"/>
                 </a:solidFill>
                 <a:latin typeface="Oswald"/>
               </a:rPr>
@@ -9012,7 +8815,7 @@
             <a:r>
               <a:rPr sz="1100" b="1" i="0" spc="250">
                 <a:solidFill>
-                  <a:srgbClr val="E54C09"/>
+                  <a:srgbClr val="FBC900"/>
                 </a:solidFill>
                 <a:latin typeface="Lato"/>
               </a:rPr>
@@ -9054,7 +8857,7 @@
             <a:r>
               <a:rPr sz="3800" b="1" i="0">
                 <a:solidFill>
-                  <a:srgbClr val="F6F1E9"/>
+                  <a:srgbClr val="FFFFFF"/>
                 </a:solidFill>
                 <a:latin typeface="Lato Black"/>
               </a:rPr>
@@ -9155,7 +8958,7 @@
                 </a:solidFill>
                 <a:latin typeface="Lato"/>
               </a:rPr>
-              <a:t>Firmamos hoy y la charla de 20 minutos la hacemos el </a:t>
+              <a:t>Firmamos hoy. ¿La charla la hacemos el </a:t>
             </a:r>
             <a:r>
               <a:rPr sz="1900" b="1" i="0">
@@ -9227,7 +9030,7 @@
                 </a:solidFill>
                 <a:latin typeface="Lato"/>
               </a:rPr>
-              <a:t>.</a:t>
+              <a:t>?</a:t>
             </a:r>
           </a:p>
         </p:txBody>
@@ -9274,11 +9077,11 @@
             <a:r>
               <a:rPr sz="1600" b="0" i="0">
                 <a:solidFill>
-                  <a:srgbClr val="F6F1E9"/>
+                  <a:srgbClr val="FFFFFF"/>
                 </a:solidFill>
                 <a:latin typeface="Lato"/>
               </a:rPr>
-              <a:t>¿cuándo se reúne? Le dejo el convenio listo para esa fecha.</a:t>
+              <a:t>¿cuándo se reúne? Le dejo el convenio listo.</a:t>
             </a:r>
           </a:p>
           <a:p>
@@ -9293,7 +9096,7 @@
             <a:r>
               <a:rPr sz="1300" b="0" i="0">
                 <a:solidFill>
-                  <a:srgbClr val="9AA4B5"/>
+                  <a:srgbClr val="D6E2F0"/>
                 </a:solidFill>
                 <a:latin typeface="Lato"/>
               </a:rPr>
@@ -9405,7 +9208,7 @@
             <a:r>
               <a:rPr sz="1100" b="0" i="0">
                 <a:solidFill>
-                  <a:srgbClr val="9AA4B5"/>
+                  <a:srgbClr val="D6E2F0"/>
                 </a:solidFill>
                 <a:latin typeface="Lato"/>
               </a:rPr>
@@ -9447,7 +9250,7 @@
             <a:r>
               <a:rPr sz="950" b="0" i="0">
                 <a:solidFill>
-                  <a:srgbClr val="9AA4B5"/>
+                  <a:srgbClr val="D6E2F0"/>
                 </a:solidFill>
                 <a:latin typeface="Lato"/>
               </a:rPr>

</xml_diff>

<commit_message>
Presentacion fondos de empleados: paleta naranja claro + crema + cafe (decision de gerencia), tarjetas blancas, naranja de marca como acento
Co-Authored-By: Claude Fable 5.1 <noreply@anthropic.com>
</commit_message>
<xml_diff>
--- a/recursos/comercial/B2B/PRESENTACION_FONDOS_EMPLEADOS_HEIIU.pptx
+++ b/recursos/comercial/B2B/PRESENTACION_FONDOS_EMPLEADOS_HEIIU.pptx
@@ -3989,7 +3989,7 @@
             <a:avLst/>
           </a:prstGeom>
           <a:solidFill>
-            <a:srgbClr val="2B5A8C"/>
+            <a:srgbClr val="F39A55"/>
           </a:solidFill>
           <a:ln>
             <a:noFill/>
@@ -4033,7 +4033,7 @@
             <a:avLst/>
           </a:prstGeom>
           <a:solidFill>
-            <a:srgbClr val="3D6FA6"/>
+            <a:srgbClr val="FFFFFF"/>
           </a:solidFill>
           <a:ln>
             <a:noFill/>
@@ -4106,9 +4106,55 @@
           </a:p>
         </p:txBody>
       </p:sp>
+      <p:sp>
+        <p:nvSpPr>
+          <p:cNvPr id="5" name="Rounded Rectangle 4"/>
+          <p:cNvSpPr/>
+          <p:nvPr/>
+        </p:nvSpPr>
+        <p:spPr>
+          <a:xfrm>
+            <a:off x="548640" y="502920"/>
+            <a:ext cx="1732970" cy="914400"/>
+          </a:xfrm>
+          <a:prstGeom prst="roundRect">
+            <a:avLst>
+              <a:gd name="adj" fmla="val 50000"/>
+            </a:avLst>
+          </a:prstGeom>
+          <a:solidFill>
+            <a:srgbClr val="E54C09"/>
+          </a:solidFill>
+          <a:ln>
+            <a:noFill/>
+          </a:ln>
+          <a:effectLst/>
+        </p:spPr>
+        <p:style>
+          <a:lnRef idx="1">
+            <a:schemeClr val="accent1"/>
+          </a:lnRef>
+          <a:fillRef idx="3">
+            <a:schemeClr val="accent1"/>
+          </a:fillRef>
+          <a:effectRef idx="2">
+            <a:schemeClr val="accent1"/>
+          </a:effectRef>
+          <a:fontRef idx="minor">
+            <a:schemeClr val="lt1"/>
+          </a:fontRef>
+        </p:style>
+        <p:txBody>
+          <a:bodyPr rtlCol="0" anchor="ctr"/>
+          <a:lstStyle/>
+          <a:p>
+            <a:pPr algn="ctr"/>
+          </a:p>
+        </p:txBody>
+      </p:sp>
       <p:pic>
         <p:nvPicPr>
-          <p:cNvPr id="5" name="Picture 4" descr="logo_heiiu_transparente.png"/>
+          <p:cNvPr id="6" name="Picture 5" descr="logo_heiiu_transparente.png"/>
           <p:cNvPicPr>
             <a:picLocks noChangeAspect="1"/>
           </p:cNvPicPr>
@@ -4122,8 +4168,8 @@
         </p:blipFill>
         <p:spPr>
           <a:xfrm>
-            <a:off x="548640" y="502920"/>
-            <a:ext cx="2032552" cy="1143000"/>
+            <a:off x="731520" y="576072"/>
+            <a:ext cx="1365875" cy="768096"/>
           </a:xfrm>
           <a:prstGeom prst="rect">
             <a:avLst/>
@@ -4132,7 +4178,7 @@
       </p:pic>
       <p:sp>
         <p:nvSpPr>
-          <p:cNvPr id="6" name="TextBox 5"/>
+          <p:cNvPr id="7" name="TextBox 6"/>
           <p:cNvSpPr txBox="1"/>
           <p:nvPr/>
         </p:nvSpPr>
@@ -4163,7 +4209,7 @@
             <a:r>
               <a:rPr sz="1100" b="1" i="0" spc="250">
                 <a:solidFill>
-                  <a:srgbClr val="FBC900"/>
+                  <a:srgbClr val="3B2A20"/>
                 </a:solidFill>
                 <a:latin typeface="Lato"/>
               </a:rPr>
@@ -4174,7 +4220,7 @@
       </p:sp>
       <p:sp>
         <p:nvSpPr>
-          <p:cNvPr id="7" name="TextBox 6"/>
+          <p:cNvPr id="8" name="TextBox 7"/>
           <p:cNvSpPr txBox="1"/>
           <p:nvPr/>
         </p:nvSpPr>
@@ -4205,7 +4251,7 @@
             <a:r>
               <a:rPr sz="4200" b="1" i="0">
                 <a:solidFill>
-                  <a:srgbClr val="FFFFFF"/>
+                  <a:srgbClr val="3B2A20"/>
                 </a:solidFill>
                 <a:latin typeface="Lato Black"/>
               </a:rPr>
@@ -4214,7 +4260,7 @@
             <a:r>
               <a:rPr sz="4200" b="1" i="0">
                 <a:solidFill>
-                  <a:srgbClr val="FBC900"/>
+                  <a:srgbClr val="FFFFFF"/>
                 </a:solidFill>
                 <a:latin typeface="Lato Black"/>
               </a:rPr>
@@ -4225,7 +4271,7 @@
       </p:sp>
       <p:sp>
         <p:nvSpPr>
-          <p:cNvPr id="8" name="TextBox 7"/>
+          <p:cNvPr id="9" name="TextBox 8"/>
           <p:cNvSpPr txBox="1"/>
           <p:nvPr/>
         </p:nvSpPr>
@@ -4256,7 +4302,7 @@
             <a:r>
               <a:rPr sz="1800" b="0" i="0">
                 <a:solidFill>
-                  <a:srgbClr val="D6E2F0"/>
+                  <a:srgbClr val="6B4A33"/>
                 </a:solidFill>
                 <a:latin typeface="Lato"/>
               </a:rPr>
@@ -4267,7 +4313,7 @@
       </p:sp>
       <p:sp>
         <p:nvSpPr>
-          <p:cNvPr id="9" name="TextBox 8"/>
+          <p:cNvPr id="10" name="TextBox 9"/>
           <p:cNvSpPr txBox="1"/>
           <p:nvPr/>
         </p:nvSpPr>
@@ -4298,7 +4344,7 @@
             <a:r>
               <a:rPr sz="1300" b="0" i="0">
                 <a:solidFill>
-                  <a:srgbClr val="D6E2F0"/>
+                  <a:srgbClr val="6B4A33"/>
                 </a:solidFill>
                 <a:latin typeface="Lato"/>
               </a:rPr>
@@ -4307,7 +4353,7 @@
             <a:r>
               <a:rPr sz="1300" b="0" i="0">
                 <a:solidFill>
-                  <a:srgbClr val="D6E2F0"/>
+                  <a:srgbClr val="6B4A33"/>
                 </a:solidFill>
                 <a:latin typeface="Lato"/>
               </a:rPr>
@@ -4316,7 +4362,7 @@
             <a:r>
               <a:rPr sz="1300" b="0" i="0">
                 <a:solidFill>
-                  <a:srgbClr val="D6E2F0"/>
+                  <a:srgbClr val="6B4A33"/>
                 </a:solidFill>
                 <a:latin typeface="Lato"/>
               </a:rPr>
@@ -4327,7 +4373,7 @@
       </p:sp>
       <p:sp>
         <p:nvSpPr>
-          <p:cNvPr id="10" name="TextBox 9"/>
+          <p:cNvPr id="11" name="TextBox 10"/>
           <p:cNvSpPr txBox="1"/>
           <p:nvPr/>
         </p:nvSpPr>
@@ -4358,7 +4404,7 @@
             <a:r>
               <a:rPr sz="9600" b="0" i="0">
                 <a:solidFill>
-                  <a:srgbClr val="FBC900"/>
+                  <a:srgbClr val="E54C09"/>
                 </a:solidFill>
                 <a:latin typeface="Oswald"/>
               </a:rPr>
@@ -4369,7 +4415,7 @@
       </p:sp>
       <p:sp>
         <p:nvSpPr>
-          <p:cNvPr id="11" name="TextBox 10"/>
+          <p:cNvPr id="12" name="TextBox 11"/>
           <p:cNvSpPr txBox="1"/>
           <p:nvPr/>
         </p:nvSpPr>
@@ -4400,7 +4446,7 @@
             <a:r>
               <a:rPr sz="1500" b="0" i="0">
                 <a:solidFill>
-                  <a:srgbClr val="FFFFFF"/>
+                  <a:srgbClr val="3B2A20"/>
                 </a:solidFill>
                 <a:latin typeface="Lato"/>
               </a:rPr>
@@ -4411,7 +4457,7 @@
       </p:sp>
       <p:sp>
         <p:nvSpPr>
-          <p:cNvPr id="12" name="TextBox 11"/>
+          <p:cNvPr id="13" name="TextBox 12"/>
           <p:cNvSpPr txBox="1"/>
           <p:nvPr/>
         </p:nvSpPr>
@@ -4442,7 +4488,7 @@
             <a:r>
               <a:rPr sz="7200" b="0" i="0">
                 <a:solidFill>
-                  <a:srgbClr val="FFFFFF"/>
+                  <a:srgbClr val="E54C09"/>
                 </a:solidFill>
                 <a:latin typeface="Oswald"/>
               </a:rPr>
@@ -4453,7 +4499,7 @@
       </p:sp>
       <p:sp>
         <p:nvSpPr>
-          <p:cNvPr id="13" name="TextBox 12"/>
+          <p:cNvPr id="14" name="TextBox 13"/>
           <p:cNvSpPr txBox="1"/>
           <p:nvPr/>
         </p:nvSpPr>
@@ -4484,7 +4530,7 @@
             <a:r>
               <a:rPr sz="1500" b="0" i="0">
                 <a:solidFill>
-                  <a:srgbClr val="FFFFFF"/>
+                  <a:srgbClr val="3B2A20"/>
                 </a:solidFill>
                 <a:latin typeface="Lato"/>
               </a:rPr>
@@ -4526,7 +4572,7 @@
             <a:avLst/>
           </a:prstGeom>
           <a:solidFill>
-            <a:srgbClr val="F7F3EC"/>
+            <a:srgbClr val="FBF5EE"/>
           </a:solidFill>
           <a:ln>
             <a:noFill/>
@@ -4564,7 +4610,7 @@
         <p:spPr>
           <a:xfrm>
             <a:off x="548640" y="384048"/>
-            <a:ext cx="1417320" cy="566928"/>
+            <a:ext cx="1114470" cy="566928"/>
           </a:xfrm>
           <a:prstGeom prst="roundRect">
             <a:avLst>
@@ -4572,7 +4618,7 @@
             </a:avLst>
           </a:prstGeom>
           <a:solidFill>
-            <a:srgbClr val="2B5A8C"/>
+            <a:srgbClr val="E54C09"/>
           </a:solidFill>
           <a:ln>
             <a:noFill/>
@@ -4742,7 +4788,7 @@
             <a:r>
               <a:rPr sz="3600" b="1" i="0">
                 <a:solidFill>
-                  <a:srgbClr val="1E3A5F"/>
+                  <a:srgbClr val="3B2A20"/>
                 </a:solidFill>
                 <a:latin typeface="Lato Black"/>
               </a:rPr>
@@ -4814,7 +4860,7 @@
           </a:solidFill>
           <a:ln w="9525">
             <a:solidFill>
-              <a:srgbClr val="DDE4EE"/>
+              <a:srgbClr val="F0DCC8"/>
             </a:solidFill>
           </a:ln>
           <a:effectLst/>
@@ -4918,7 +4964,7 @@
             <a:r>
               <a:rPr sz="4600" b="0" i="0">
                 <a:solidFill>
-                  <a:srgbClr val="1E3A5F"/>
+                  <a:srgbClr val="3B2A20"/>
                 </a:solidFill>
                 <a:latin typeface="Oswald"/>
               </a:rPr>
@@ -4990,7 +5036,7 @@
           </a:solidFill>
           <a:ln w="9525">
             <a:solidFill>
-              <a:srgbClr val="DDE4EE"/>
+              <a:srgbClr val="F0DCC8"/>
             </a:solidFill>
           </a:ln>
           <a:effectLst/>
@@ -5094,7 +5140,7 @@
             <a:r>
               <a:rPr sz="4600" b="0" i="0">
                 <a:solidFill>
-                  <a:srgbClr val="1E3A5F"/>
+                  <a:srgbClr val="3B2A20"/>
                 </a:solidFill>
                 <a:latin typeface="Oswald"/>
               </a:rPr>
@@ -5166,7 +5212,7 @@
           </a:solidFill>
           <a:ln w="9525">
             <a:solidFill>
-              <a:srgbClr val="DDE4EE"/>
+              <a:srgbClr val="F0DCC8"/>
             </a:solidFill>
           </a:ln>
           <a:effectLst/>
@@ -5270,7 +5316,7 @@
             <a:r>
               <a:rPr sz="4600" b="0" i="0">
                 <a:solidFill>
-                  <a:srgbClr val="1E3A5F"/>
+                  <a:srgbClr val="3B2A20"/>
                 </a:solidFill>
                 <a:latin typeface="Oswald"/>
               </a:rPr>
@@ -5342,7 +5388,7 @@
           </a:solidFill>
           <a:ln w="9525">
             <a:solidFill>
-              <a:srgbClr val="DDE4EE"/>
+              <a:srgbClr val="F0DCC8"/>
             </a:solidFill>
           </a:ln>
           <a:effectLst/>
@@ -5446,7 +5492,7 @@
             <a:r>
               <a:rPr sz="4600" b="0" i="0">
                 <a:solidFill>
-                  <a:srgbClr val="1E3A5F"/>
+                  <a:srgbClr val="3B2A20"/>
                 </a:solidFill>
                 <a:latin typeface="Oswald"/>
               </a:rPr>
@@ -5530,7 +5576,7 @@
             <a:avLst/>
           </a:prstGeom>
           <a:solidFill>
-            <a:srgbClr val="F7F3EC"/>
+            <a:srgbClr val="FBF5EE"/>
           </a:solidFill>
           <a:ln>
             <a:noFill/>
@@ -5568,7 +5614,7 @@
         <p:spPr>
           <a:xfrm>
             <a:off x="548640" y="384048"/>
-            <a:ext cx="1417320" cy="566928"/>
+            <a:ext cx="1114470" cy="566928"/>
           </a:xfrm>
           <a:prstGeom prst="roundRect">
             <a:avLst>
@@ -5576,7 +5622,7 @@
             </a:avLst>
           </a:prstGeom>
           <a:solidFill>
-            <a:srgbClr val="2B5A8C"/>
+            <a:srgbClr val="E54C09"/>
           </a:solidFill>
           <a:ln>
             <a:noFill/>
@@ -5746,7 +5792,7 @@
             <a:r>
               <a:rPr sz="3600" b="1" i="0">
                 <a:solidFill>
-                  <a:srgbClr val="1E3A5F"/>
+                  <a:srgbClr val="3B2A20"/>
                 </a:solidFill>
                 <a:latin typeface="Lato Black"/>
               </a:rPr>
@@ -5874,7 +5920,7 @@
             <a:r>
               <a:rPr sz="1100" b="1" i="0" spc="200">
                 <a:solidFill>
-                  <a:srgbClr val="1E3A5F"/>
+                  <a:srgbClr val="3B2A20"/>
                 </a:solidFill>
                 <a:latin typeface="Lato"/>
               </a:rPr>
@@ -6002,7 +6048,7 @@
             <a:r>
               <a:rPr sz="1100" b="1" i="0" spc="200">
                 <a:solidFill>
-                  <a:srgbClr val="1E3A5F"/>
+                  <a:srgbClr val="3B2A20"/>
                 </a:solidFill>
                 <a:latin typeface="Lato"/>
               </a:rPr>
@@ -6130,7 +6176,7 @@
             <a:r>
               <a:rPr sz="1100" b="1" i="0" spc="200">
                 <a:solidFill>
-                  <a:srgbClr val="1E3A5F"/>
+                  <a:srgbClr val="3B2A20"/>
                 </a:solidFill>
                 <a:latin typeface="Lato"/>
               </a:rPr>
@@ -6258,7 +6304,7 @@
             <a:r>
               <a:rPr sz="1100" b="1" i="0" spc="200">
                 <a:solidFill>
-                  <a:srgbClr val="1E3A5F"/>
+                  <a:srgbClr val="3B2A20"/>
                 </a:solidFill>
                 <a:latin typeface="Lato"/>
               </a:rPr>
@@ -6386,7 +6432,7 @@
             <a:r>
               <a:rPr sz="1100" b="1" i="0" spc="200">
                 <a:solidFill>
-                  <a:srgbClr val="1E3A5F"/>
+                  <a:srgbClr val="3B2A20"/>
                 </a:solidFill>
                 <a:latin typeface="Lato"/>
               </a:rPr>
@@ -6514,7 +6560,7 @@
             <a:r>
               <a:rPr sz="1100" b="1" i="0" spc="200">
                 <a:solidFill>
-                  <a:srgbClr val="1E3A5F"/>
+                  <a:srgbClr val="3B2A20"/>
                 </a:solidFill>
                 <a:latin typeface="Lato"/>
               </a:rPr>
@@ -6598,7 +6644,7 @@
             <a:avLst/>
           </a:prstGeom>
           <a:solidFill>
-            <a:srgbClr val="F7F3EC"/>
+            <a:srgbClr val="FBF5EE"/>
           </a:solidFill>
           <a:ln>
             <a:noFill/>
@@ -6636,7 +6682,7 @@
         <p:spPr>
           <a:xfrm>
             <a:off x="548640" y="384048"/>
-            <a:ext cx="1417320" cy="566928"/>
+            <a:ext cx="1114470" cy="566928"/>
           </a:xfrm>
           <a:prstGeom prst="roundRect">
             <a:avLst>
@@ -6644,7 +6690,7 @@
             </a:avLst>
           </a:prstGeom>
           <a:solidFill>
-            <a:srgbClr val="2B5A8C"/>
+            <a:srgbClr val="E54C09"/>
           </a:solidFill>
           <a:ln>
             <a:noFill/>
@@ -6814,7 +6860,7 @@
             <a:r>
               <a:rPr sz="3600" b="1" i="0">
                 <a:solidFill>
-                  <a:srgbClr val="1E3A5F"/>
+                  <a:srgbClr val="3B2A20"/>
                 </a:solidFill>
                 <a:latin typeface="Lato Black"/>
               </a:rPr>
@@ -6989,7 +7035,7 @@
             </a:avLst>
           </a:prstGeom>
           <a:solidFill>
-            <a:srgbClr val="2B5A8C"/>
+            <a:srgbClr val="F39A55"/>
           </a:solidFill>
           <a:ln>
             <a:noFill/>
@@ -7033,7 +7079,7 @@
             <a:avLst/>
           </a:prstGeom>
           <a:solidFill>
-            <a:srgbClr val="FBC900"/>
+            <a:srgbClr val="3B2A20"/>
           </a:solidFill>
           <a:ln>
             <a:noFill/>
@@ -7095,7 +7141,7 @@
             <a:r>
               <a:rPr sz="4800" b="0" i="0">
                 <a:solidFill>
-                  <a:srgbClr val="FBC900"/>
+                  <a:srgbClr val="3B2A20"/>
                 </a:solidFill>
                 <a:latin typeface="Oswald"/>
               </a:rPr>
@@ -7137,7 +7183,7 @@
             <a:r>
               <a:rPr sz="1500" b="0" i="0">
                 <a:solidFill>
-                  <a:srgbClr val="FFFFFF"/>
+                  <a:srgbClr val="3B2A20"/>
                 </a:solidFill>
                 <a:latin typeface="Lato"/>
               </a:rPr>
@@ -7179,7 +7225,7 @@
             <a:avLst/>
           </a:prstGeom>
           <a:solidFill>
-            <a:srgbClr val="F7F3EC"/>
+            <a:srgbClr val="FBF5EE"/>
           </a:solidFill>
           <a:ln>
             <a:noFill/>
@@ -7217,7 +7263,7 @@
         <p:spPr>
           <a:xfrm>
             <a:off x="548640" y="384048"/>
-            <a:ext cx="1417320" cy="566928"/>
+            <a:ext cx="1114470" cy="566928"/>
           </a:xfrm>
           <a:prstGeom prst="roundRect">
             <a:avLst>
@@ -7225,7 +7271,7 @@
             </a:avLst>
           </a:prstGeom>
           <a:solidFill>
-            <a:srgbClr val="2B5A8C"/>
+            <a:srgbClr val="E54C09"/>
           </a:solidFill>
           <a:ln>
             <a:noFill/>
@@ -7395,7 +7441,7 @@
             <a:r>
               <a:rPr sz="3600" b="1" i="0">
                 <a:solidFill>
-                  <a:srgbClr val="1E3A5F"/>
+                  <a:srgbClr val="3B2A20"/>
                 </a:solidFill>
                 <a:latin typeface="Lato Black"/>
               </a:rPr>
@@ -7467,7 +7513,7 @@
           </a:solidFill>
           <a:ln w="9525">
             <a:solidFill>
-              <a:srgbClr val="DDE4EE"/>
+              <a:srgbClr val="F0DCC8"/>
             </a:solidFill>
           </a:ln>
           <a:effectLst/>
@@ -7660,7 +7706,7 @@
             </a:avLst>
           </a:prstGeom>
           <a:solidFill>
-            <a:srgbClr val="2B5A8C"/>
+            <a:srgbClr val="F39A55"/>
           </a:solidFill>
           <a:ln>
             <a:noFill/>
@@ -7722,7 +7768,7 @@
             <a:r>
               <a:rPr sz="1100" b="1" i="0" spc="200">
                 <a:solidFill>
-                  <a:srgbClr val="FBC900"/>
+                  <a:srgbClr val="3B2A20"/>
                 </a:solidFill>
                 <a:latin typeface="Lato"/>
               </a:rPr>
@@ -7764,7 +7810,7 @@
             <a:r>
               <a:rPr sz="1800" b="1" i="0">
                 <a:solidFill>
-                  <a:srgbClr val="FBC900"/>
+                  <a:srgbClr val="FFFFFF"/>
                 </a:solidFill>
                 <a:latin typeface="Lato"/>
               </a:rPr>
@@ -7773,7 +7819,7 @@
             <a:r>
               <a:rPr sz="1800" b="0" i="0">
                 <a:solidFill>
-                  <a:srgbClr val="FFFFFF"/>
+                  <a:srgbClr val="3B2A20"/>
                 </a:solidFill>
                 <a:latin typeface="Lato"/>
               </a:rPr>
@@ -7792,7 +7838,7 @@
             <a:r>
               <a:rPr sz="1800" b="1" i="0">
                 <a:solidFill>
-                  <a:srgbClr val="FBC900"/>
+                  <a:srgbClr val="FFFFFF"/>
                 </a:solidFill>
                 <a:latin typeface="Lato"/>
               </a:rPr>
@@ -7801,7 +7847,7 @@
             <a:r>
               <a:rPr sz="1800" b="0" i="0">
                 <a:solidFill>
-                  <a:srgbClr val="FFFFFF"/>
+                  <a:srgbClr val="3B2A20"/>
                 </a:solidFill>
                 <a:latin typeface="Lato"/>
               </a:rPr>
@@ -7820,7 +7866,7 @@
             <a:r>
               <a:rPr sz="1800" b="1" i="0">
                 <a:solidFill>
-                  <a:srgbClr val="FBC900"/>
+                  <a:srgbClr val="FFFFFF"/>
                 </a:solidFill>
                 <a:latin typeface="Lato"/>
               </a:rPr>
@@ -7829,7 +7875,7 @@
             <a:r>
               <a:rPr sz="1800" b="0" i="0">
                 <a:solidFill>
-                  <a:srgbClr val="FFFFFF"/>
+                  <a:srgbClr val="3B2A20"/>
                 </a:solidFill>
                 <a:latin typeface="Lato"/>
               </a:rPr>
@@ -7871,7 +7917,7 @@
             <a:avLst/>
           </a:prstGeom>
           <a:solidFill>
-            <a:srgbClr val="2B5A8C"/>
+            <a:srgbClr val="F39A55"/>
           </a:solidFill>
           <a:ln>
             <a:noFill/>
@@ -7909,7 +7955,7 @@
         <p:spPr>
           <a:xfrm>
             <a:off x="548640" y="384048"/>
-            <a:ext cx="1417320" cy="566928"/>
+            <a:ext cx="1114470" cy="566928"/>
           </a:xfrm>
           <a:prstGeom prst="roundRect">
             <a:avLst>
@@ -7917,7 +7963,7 @@
             </a:avLst>
           </a:prstGeom>
           <a:solidFill>
-            <a:srgbClr val="3D6FA6"/>
+            <a:srgbClr val="E54C09"/>
           </a:solidFill>
           <a:ln>
             <a:noFill/>
@@ -8003,7 +8049,7 @@
             <a:r>
               <a:rPr sz="1200" b="0" i="0">
                 <a:solidFill>
-                  <a:srgbClr val="D6E2F0"/>
+                  <a:srgbClr val="6B4A33"/>
                 </a:solidFill>
                 <a:latin typeface="Oswald"/>
               </a:rPr>
@@ -8045,7 +8091,7 @@
             <a:r>
               <a:rPr sz="1100" b="1" i="0" spc="250">
                 <a:solidFill>
-                  <a:srgbClr val="FBC900"/>
+                  <a:srgbClr val="3B2A20"/>
                 </a:solidFill>
                 <a:latin typeface="Lato"/>
               </a:rPr>
@@ -8087,7 +8133,7 @@
             <a:r>
               <a:rPr sz="3600" b="1" i="0">
                 <a:solidFill>
-                  <a:srgbClr val="FFFFFF"/>
+                  <a:srgbClr val="3B2A20"/>
                 </a:solidFill>
                 <a:latin typeface="Lato Black"/>
               </a:rPr>
@@ -8129,7 +8175,7 @@
             <a:r>
               <a:rPr sz="950" b="0" i="0">
                 <a:solidFill>
-                  <a:srgbClr val="D6E2F0"/>
+                  <a:srgbClr val="6B4A33"/>
                 </a:solidFill>
                 <a:latin typeface="Lato"/>
               </a:rPr>
@@ -8155,7 +8201,7 @@
             </a:avLst>
           </a:prstGeom>
           <a:solidFill>
-            <a:srgbClr val="3D6FA6"/>
+            <a:srgbClr val="FFFFFF"/>
           </a:solidFill>
           <a:ln>
             <a:noFill/>
@@ -8217,7 +8263,7 @@
             <a:r>
               <a:rPr sz="5400" b="0" i="0">
                 <a:solidFill>
-                  <a:srgbClr val="FBC900"/>
+                  <a:srgbClr val="E54C09"/>
                 </a:solidFill>
                 <a:latin typeface="Oswald"/>
               </a:rPr>
@@ -8259,7 +8305,7 @@
             <a:r>
               <a:rPr sz="1050" b="1" i="0" spc="200">
                 <a:solidFill>
-                  <a:srgbClr val="FBC900"/>
+                  <a:srgbClr val="3B2A20"/>
                 </a:solidFill>
                 <a:latin typeface="Lato"/>
               </a:rPr>
@@ -8301,7 +8347,7 @@
             <a:r>
               <a:rPr sz="1700" b="0" i="0">
                 <a:solidFill>
-                  <a:srgbClr val="FFFFFF"/>
+                  <a:srgbClr val="2B3445"/>
                 </a:solidFill>
                 <a:latin typeface="Lato"/>
               </a:rPr>
@@ -8327,7 +8373,7 @@
             </a:avLst>
           </a:prstGeom>
           <a:solidFill>
-            <a:srgbClr val="3D6FA6"/>
+            <a:srgbClr val="FFFFFF"/>
           </a:solidFill>
           <a:ln>
             <a:noFill/>
@@ -8389,7 +8435,7 @@
             <a:r>
               <a:rPr sz="5400" b="0" i="0">
                 <a:solidFill>
-                  <a:srgbClr val="FBC900"/>
+                  <a:srgbClr val="E54C09"/>
                 </a:solidFill>
                 <a:latin typeface="Oswald"/>
               </a:rPr>
@@ -8431,7 +8477,7 @@
             <a:r>
               <a:rPr sz="1050" b="1" i="0" spc="200">
                 <a:solidFill>
-                  <a:srgbClr val="FBC900"/>
+                  <a:srgbClr val="3B2A20"/>
                 </a:solidFill>
                 <a:latin typeface="Lato"/>
               </a:rPr>
@@ -8473,7 +8519,7 @@
             <a:r>
               <a:rPr sz="1700" b="0" i="0">
                 <a:solidFill>
-                  <a:srgbClr val="FFFFFF"/>
+                  <a:srgbClr val="2B3445"/>
                 </a:solidFill>
                 <a:latin typeface="Lato"/>
               </a:rPr>
@@ -8499,7 +8545,7 @@
             </a:avLst>
           </a:prstGeom>
           <a:solidFill>
-            <a:srgbClr val="3D6FA6"/>
+            <a:srgbClr val="FFFFFF"/>
           </a:solidFill>
           <a:ln>
             <a:noFill/>
@@ -8561,7 +8607,7 @@
             <a:r>
               <a:rPr sz="5400" b="0" i="0">
                 <a:solidFill>
-                  <a:srgbClr val="FBC900"/>
+                  <a:srgbClr val="E54C09"/>
                 </a:solidFill>
                 <a:latin typeface="Oswald"/>
               </a:rPr>
@@ -8603,7 +8649,7 @@
             <a:r>
               <a:rPr sz="1050" b="1" i="0" spc="200">
                 <a:solidFill>
-                  <a:srgbClr val="FBC900"/>
+                  <a:srgbClr val="3B2A20"/>
                 </a:solidFill>
                 <a:latin typeface="Lato"/>
               </a:rPr>
@@ -8645,7 +8691,7 @@
             <a:r>
               <a:rPr sz="1700" b="0" i="0">
                 <a:solidFill>
-                  <a:srgbClr val="FFFFFF"/>
+                  <a:srgbClr val="2B3445"/>
                 </a:solidFill>
                 <a:latin typeface="Lato"/>
               </a:rPr>
@@ -8687,7 +8733,7 @@
             <a:avLst/>
           </a:prstGeom>
           <a:solidFill>
-            <a:srgbClr val="2B5A8C"/>
+            <a:srgbClr val="F39A55"/>
           </a:solidFill>
           <a:ln>
             <a:noFill/>
@@ -8716,9 +8762,55 @@
           </a:p>
         </p:txBody>
       </p:sp>
+      <p:sp>
+        <p:nvSpPr>
+          <p:cNvPr id="3" name="Rounded Rectangle 2"/>
+          <p:cNvSpPr/>
+          <p:nvPr/>
+        </p:nvSpPr>
+        <p:spPr>
+          <a:xfrm>
+            <a:off x="548640" y="457200"/>
+            <a:ext cx="1407444" cy="731520"/>
+          </a:xfrm>
+          <a:prstGeom prst="roundRect">
+            <a:avLst>
+              <a:gd name="adj" fmla="val 50000"/>
+            </a:avLst>
+          </a:prstGeom>
+          <a:solidFill>
+            <a:srgbClr val="E54C09"/>
+          </a:solidFill>
+          <a:ln>
+            <a:noFill/>
+          </a:ln>
+          <a:effectLst/>
+        </p:spPr>
+        <p:style>
+          <a:lnRef idx="1">
+            <a:schemeClr val="accent1"/>
+          </a:lnRef>
+          <a:fillRef idx="3">
+            <a:schemeClr val="accent1"/>
+          </a:fillRef>
+          <a:effectRef idx="2">
+            <a:schemeClr val="accent1"/>
+          </a:effectRef>
+          <a:fontRef idx="minor">
+            <a:schemeClr val="lt1"/>
+          </a:fontRef>
+        </p:style>
+        <p:txBody>
+          <a:bodyPr rtlCol="0" anchor="ctr"/>
+          <a:lstStyle/>
+          <a:p>
+            <a:pPr algn="ctr"/>
+          </a:p>
+        </p:txBody>
+      </p:sp>
       <p:pic>
         <p:nvPicPr>
-          <p:cNvPr id="3" name="Picture 2" descr="logo_heiiu_transparente.png"/>
+          <p:cNvPr id="4" name="Picture 3" descr="logo_heiiu_transparente.png"/>
           <p:cNvPicPr>
             <a:picLocks noChangeAspect="1"/>
           </p:cNvPicPr>
@@ -8732,8 +8824,8 @@
         </p:blipFill>
         <p:spPr>
           <a:xfrm>
-            <a:off x="548640" y="457200"/>
-            <a:ext cx="1626042" cy="914400"/>
+            <a:off x="731520" y="530352"/>
+            <a:ext cx="1040667" cy="585216"/>
           </a:xfrm>
           <a:prstGeom prst="rect">
             <a:avLst/>
@@ -8742,14 +8834,14 @@
       </p:pic>
       <p:sp>
         <p:nvSpPr>
-          <p:cNvPr id="4" name="TextBox 3"/>
+          <p:cNvPr id="5" name="TextBox 4"/>
           <p:cNvSpPr txBox="1"/>
           <p:nvPr/>
         </p:nvSpPr>
         <p:spPr>
           <a:xfrm>
             <a:off x="9418320" y="457200"/>
-            <a:ext cx="2286000" cy="914400"/>
+            <a:ext cx="2286000" cy="731520"/>
           </a:xfrm>
           <a:prstGeom prst="rect">
             <a:avLst/>
@@ -8773,7 +8865,7 @@
             <a:r>
               <a:rPr sz="1200" b="0" i="0">
                 <a:solidFill>
-                  <a:srgbClr val="D6E2F0"/>
+                  <a:srgbClr val="6B4A33"/>
                 </a:solidFill>
                 <a:latin typeface="Oswald"/>
               </a:rPr>
@@ -8784,7 +8876,7 @@
       </p:sp>
       <p:sp>
         <p:nvSpPr>
-          <p:cNvPr id="5" name="TextBox 4"/>
+          <p:cNvPr id="6" name="TextBox 5"/>
           <p:cNvSpPr txBox="1"/>
           <p:nvPr/>
         </p:nvSpPr>
@@ -8815,7 +8907,7 @@
             <a:r>
               <a:rPr sz="1100" b="1" i="0" spc="250">
                 <a:solidFill>
-                  <a:srgbClr val="FBC900"/>
+                  <a:srgbClr val="3B2A20"/>
                 </a:solidFill>
                 <a:latin typeface="Lato"/>
               </a:rPr>
@@ -8826,7 +8918,7 @@
       </p:sp>
       <p:sp>
         <p:nvSpPr>
-          <p:cNvPr id="6" name="TextBox 5"/>
+          <p:cNvPr id="7" name="TextBox 6"/>
           <p:cNvSpPr txBox="1"/>
           <p:nvPr/>
         </p:nvSpPr>
@@ -8857,7 +8949,7 @@
             <a:r>
               <a:rPr sz="3800" b="1" i="0">
                 <a:solidFill>
-                  <a:srgbClr val="FFFFFF"/>
+                  <a:srgbClr val="3B2A20"/>
                 </a:solidFill>
                 <a:latin typeface="Lato Black"/>
               </a:rPr>
@@ -8866,7 +8958,7 @@
             <a:r>
               <a:rPr sz="3800" b="1" i="0">
                 <a:solidFill>
-                  <a:srgbClr val="FBC900"/>
+                  <a:srgbClr val="FFFFFF"/>
                 </a:solidFill>
                 <a:latin typeface="Lato Black"/>
               </a:rPr>
@@ -8877,7 +8969,7 @@
       </p:sp>
       <p:sp>
         <p:nvSpPr>
-          <p:cNvPr id="7" name="Rounded Rectangle 6"/>
+          <p:cNvPr id="8" name="Rounded Rectangle 7"/>
           <p:cNvSpPr/>
           <p:nvPr/>
         </p:nvSpPr>
@@ -8923,7 +9015,7 @@
       </p:sp>
       <p:sp>
         <p:nvSpPr>
-          <p:cNvPr id="8" name="TextBox 7"/>
+          <p:cNvPr id="9" name="TextBox 8"/>
           <p:cNvSpPr txBox="1"/>
           <p:nvPr/>
         </p:nvSpPr>
@@ -9037,7 +9129,7 @@
       </p:sp>
       <p:sp>
         <p:nvSpPr>
-          <p:cNvPr id="9" name="TextBox 8"/>
+          <p:cNvPr id="10" name="TextBox 9"/>
           <p:cNvSpPr txBox="1"/>
           <p:nvPr/>
         </p:nvSpPr>
@@ -9068,7 +9160,7 @@
             <a:r>
               <a:rPr sz="1600" b="1" i="0">
                 <a:solidFill>
-                  <a:srgbClr val="FBC900"/>
+                  <a:srgbClr val="3B2A20"/>
                 </a:solidFill>
                 <a:latin typeface="Lato"/>
               </a:rPr>
@@ -9077,7 +9169,7 @@
             <a:r>
               <a:rPr sz="1600" b="0" i="0">
                 <a:solidFill>
-                  <a:srgbClr val="FFFFFF"/>
+                  <a:srgbClr val="3B2A20"/>
                 </a:solidFill>
                 <a:latin typeface="Lato"/>
               </a:rPr>
@@ -9096,7 +9188,7 @@
             <a:r>
               <a:rPr sz="1300" b="0" i="0">
                 <a:solidFill>
-                  <a:srgbClr val="D6E2F0"/>
+                  <a:srgbClr val="6B4A33"/>
                 </a:solidFill>
                 <a:latin typeface="Lato"/>
               </a:rPr>
@@ -9107,7 +9199,7 @@
       </p:sp>
       <p:sp>
         <p:nvSpPr>
-          <p:cNvPr id="10" name="Rounded Rectangle 9"/>
+          <p:cNvPr id="11" name="Rounded Rectangle 10"/>
           <p:cNvSpPr/>
           <p:nvPr/>
         </p:nvSpPr>
@@ -9153,7 +9245,7 @@
       </p:sp>
       <p:pic>
         <p:nvPicPr>
-          <p:cNvPr id="11" name="Picture 10" descr="_convenio_entidad_miniatura.png"/>
+          <p:cNvPr id="12" name="Picture 11" descr="_convenio_entidad_miniatura.png"/>
           <p:cNvPicPr>
             <a:picLocks noChangeAspect="1"/>
           </p:cNvPicPr>
@@ -9177,7 +9269,7 @@
       </p:pic>
       <p:sp>
         <p:nvSpPr>
-          <p:cNvPr id="12" name="TextBox 11"/>
+          <p:cNvPr id="13" name="TextBox 12"/>
           <p:cNvSpPr txBox="1"/>
           <p:nvPr/>
         </p:nvSpPr>
@@ -9208,7 +9300,7 @@
             <a:r>
               <a:rPr sz="1100" b="0" i="0">
                 <a:solidFill>
-                  <a:srgbClr val="D6E2F0"/>
+                  <a:srgbClr val="6B4A33"/>
                 </a:solidFill>
                 <a:latin typeface="Lato"/>
               </a:rPr>
@@ -9219,7 +9311,7 @@
       </p:sp>
       <p:sp>
         <p:nvSpPr>
-          <p:cNvPr id="13" name="TextBox 12"/>
+          <p:cNvPr id="14" name="TextBox 13"/>
           <p:cNvSpPr txBox="1"/>
           <p:nvPr/>
         </p:nvSpPr>
@@ -9250,7 +9342,7 @@
             <a:r>
               <a:rPr sz="950" b="0" i="0">
                 <a:solidFill>
-                  <a:srgbClr val="D6E2F0"/>
+                  <a:srgbClr val="6B4A33"/>
                 </a:solidFill>
                 <a:latin typeface="Lato"/>
               </a:rPr>

</xml_diff>

<commit_message>
Fuera el tamano del grupo (maximo 16) de volante del decidido, hoja y propuesta para fondos y presentacion: no ayuda frente a academias de grupos chicos
Co-Authored-By: Claude Fable 5.1 <noreply@anthropic.com>
</commit_message>
<xml_diff>
--- a/recursos/comercial/B2B/PRESENTACION_FONDOS_EMPLEADOS_HEIIU.pptx
+++ b/recursos/comercial/B2B/PRESENTACION_FONDOS_EMPLEADOS_HEIIU.pptx
@@ -658,7 +658,7 @@
           <a:lstStyle/>
           <a:p>
             <a:r>
-              <a:t>QUÉ DECIR: "Programa completo, presencial, en la mañana o en la noche; con 8 afiliados o más, el horario lo pone el fondo. Un profesor por grupo de máximo 16 y evaluador externo al cierre de cada nivel. Y lo firmamos: si cumple y no avanza, devolvemos el nivel."</a:t>
+              <a:t>QUÉ DECIR: "Programa completo, presencial, en la mañana o en la noche; con 8 afiliados o más, el horario lo pone el fondo. Profesores que trabajan como coach y evaluador externo al cierre de cada nivel. Y lo firmamos: si cumple y no avanza, devolvemos el nivel."</a:t>
             </a:r>
           </a:p>
           <a:p>
@@ -888,7 +888,7 @@
           </a:p>
           <a:p>
             <a:r>
-              <a:t>Decir solo cupos reales (grupos de 16, 3 becas con nombre). Nunca "últimos cupos" si no es cierto.</a:t>
+              <a:t>Decir solo cupos reales (3 becas con nombre). Nunca "últimos cupos" si no es cierto.</a:t>
             </a:r>
           </a:p>
         </p:txBody>
@@ -5362,7 +5362,7 @@
                 </a:solidFill>
                 <a:latin typeface="Lato"/>
               </a:rPr>
-              <a:t>De A1 a B2, presencial, grupos de 16</a:t>
+              <a:t>De A1 a B2, presencial y certificado</a:t>
             </a:r>
           </a:p>
         </p:txBody>
@@ -6222,7 +6222,7 @@
                 </a:solidFill>
                 <a:latin typeface="Lato"/>
               </a:rPr>
-              <a:t>Bilingües, uno por grupo de máximo 16</a:t>
+              <a:t>Bilingües, trabajan como coach</a:t>
             </a:r>
           </a:p>
         </p:txBody>

</xml_diff>

<commit_message>
Garantia: 'si cumples y no avanzas EN INGLES' en todas las piezas, hoja, propuesta y presentacion (el proyecto y la meta no se garantizan); calle D recortada para que quepa
Co-Authored-By: Claude Fable 5.1 <noreply@anthropic.com>
</commit_message>
<xml_diff>
--- a/recursos/comercial/B2B/PRESENTACION_FONDOS_EMPLEADOS_HEIIU.pptx
+++ b/recursos/comercial/B2B/PRESENTACION_FONDOS_EMPLEADOS_HEIIU.pptx
@@ -658,7 +658,7 @@
           <a:lstStyle/>
           <a:p>
             <a:r>
-              <a:t>QUÉ DECIR: "Programa completo, presencial, en la mañana o en la noche; con 8 afiliados o más, el horario lo pone el fondo. Profesores que trabajan como coach y evaluador externo al cierre de cada nivel. Y lo firmamos: si cumple y no avanza, devolvemos el nivel."</a:t>
+              <a:t>QUÉ DECIR: "Programa completo, presencial, en la mañana o en la noche; con 8 afiliados o más, el horario lo pone el fondo. Profesores que trabajan como coach y evaluador externo al cierre de cada nivel. Y lo firmamos: si cumple y no avanza en inglés, devolvemos el nivel."</a:t>
             </a:r>
           </a:p>
           <a:p>
@@ -6606,7 +6606,7 @@
                 </a:solidFill>
                 <a:latin typeface="Lato"/>
               </a:rPr>
-              <a:t>Cumple y no avanza: devolvemos el 100%</a:t>
+              <a:t>Cumple y no avanza en inglés: devolvemos el 100%</a:t>
             </a:r>
           </a:p>
         </p:txBody>
@@ -7851,7 +7851,7 @@
                 </a:solidFill>
                 <a:latin typeface="Lato"/>
               </a:rPr>
-              <a:t>Garantía: si cumple y no avanza, 100% de vuelta</a:t>
+              <a:t>Garantía: si cumple y no avanza en inglés, 100% de vuelta</a:t>
             </a:r>
           </a:p>
           <a:p>

</xml_diff>